<commit_message>
Presentacion - Borrando presentacion excedente y errores de tipeo
</commit_message>
<xml_diff>
--- a/DataQuality_OpenBeautyFacts.pptx
+++ b/DataQuality_OpenBeautyFacts.pptx
@@ -16,7 +16,6 @@
     <p:sldId id="261" r:id="rId9"/>
     <p:sldId id="262" r:id="rId10"/>
     <p:sldId id="263" r:id="rId11"/>
-    <p:sldId id="264" r:id="rId12"/>
   </p:sldIdLst>
   <p:sldSz cx="9144000" cy="5143500"/>
   <p:notesSz cx="5143500" cy="9144000"/>
@@ -68,24 +67,69 @@
             <a:noAutofit/>
           </a:bodyPr>
           <a:p>
-            <a:r>
-              <a:rPr lang="es-CO" sz="1800" b="0" u="none" strike="noStrike">
-                <a:solidFill>
-                  <a:schemeClr val="dk1"/>
-                </a:solidFill>
-                <a:effectLst/>
-                <a:uFillTx/>
-                <a:latin typeface="Calibri"/>
-              </a:rPr>
-              <a:t>Click to move the slide</a:t>
-            </a:r>
-            <a:endParaRPr lang="es-CO" sz="1800" b="0" u="none" strike="noStrike">
-              <a:solidFill>
-                <a:schemeClr val="dk1"/>
-              </a:solidFill>
-              <a:effectLst/>
-              <a:uFillTx/>
-              <a:latin typeface="Calibri"/>
+            <a:pPr algn="ctr"/>
+            <a:r>
+              <a:rPr lang="es-CO" sz="4400" b="0" u="none" strike="noStrike">
+                <a:solidFill>
+                  <a:srgbClr val="000000"/>
+                </a:solidFill>
+                <a:effectLst/>
+                <a:uFillTx/>
+                <a:latin typeface="Arial"/>
+              </a:rPr>
+              <a:t>Click </a:t>
+            </a:r>
+            <a:r>
+              <a:rPr lang="es-CO" sz="4400" b="0" u="none" strike="noStrike">
+                <a:solidFill>
+                  <a:srgbClr val="000000"/>
+                </a:solidFill>
+                <a:effectLst/>
+                <a:uFillTx/>
+                <a:latin typeface="Arial"/>
+              </a:rPr>
+              <a:t>to </a:t>
+            </a:r>
+            <a:r>
+              <a:rPr lang="es-CO" sz="4400" b="0" u="none" strike="noStrike">
+                <a:solidFill>
+                  <a:srgbClr val="000000"/>
+                </a:solidFill>
+                <a:effectLst/>
+                <a:uFillTx/>
+                <a:latin typeface="Arial"/>
+              </a:rPr>
+              <a:t>mov</a:t>
+            </a:r>
+            <a:r>
+              <a:rPr lang="es-CO" sz="4400" b="0" u="none" strike="noStrike">
+                <a:solidFill>
+                  <a:srgbClr val="000000"/>
+                </a:solidFill>
+                <a:effectLst/>
+                <a:uFillTx/>
+                <a:latin typeface="Arial"/>
+              </a:rPr>
+              <a:t>e the </a:t>
+            </a:r>
+            <a:r>
+              <a:rPr lang="es-CO" sz="4400" b="0" u="none" strike="noStrike">
+                <a:solidFill>
+                  <a:srgbClr val="000000"/>
+                </a:solidFill>
+                <a:effectLst/>
+                <a:uFillTx/>
+                <a:latin typeface="Arial"/>
+              </a:rPr>
+              <a:t>slide</a:t>
+            </a:r>
+            <a:endParaRPr lang="es-CO" sz="4400" b="0" u="none" strike="noStrike">
+              <a:solidFill>
+                <a:srgbClr val="000000"/>
+              </a:solidFill>
+              <a:effectLst/>
+              <a:uFillTx/>
+              <a:latin typeface="Arial"/>
             </a:endParaRPr>
           </a:p>
         </p:txBody>
@@ -372,7 +416,7 @@
             <a:pPr indent="0" algn="r">
               <a:buNone/>
             </a:pPr>
-            <a:fld id="{9B2EC1EE-20CE-4422-BCCF-92E5B80024D8}" type="slidenum">
+            <a:fld id="{280C7770-D7B9-4D3E-A073-4157342BC579}" type="slidenum">
               <a:rPr lang="es-CO" sz="1400" b="0" u="none" strike="noStrike">
                 <a:solidFill>
                   <a:srgbClr val="000000"/>
@@ -430,7 +474,7 @@
         <p:spPr>
           <a:xfrm>
             <a:off x="685800" y="1143000"/>
-            <a:ext cx="5486040" cy="3085920"/>
+            <a:ext cx="5485680" cy="3085560"/>
           </a:xfrm>
           <a:prstGeom prst="rect">
             <a:avLst/>
@@ -453,7 +497,7 @@
         <p:spPr>
           <a:xfrm>
             <a:off x="685800" y="4400640"/>
-            <a:ext cx="5486040" cy="3600000"/>
+            <a:ext cx="5485680" cy="3599640"/>
           </a:xfrm>
           <a:prstGeom prst="rect">
             <a:avLst/>
@@ -495,7 +539,7 @@
         <p:spPr>
           <a:xfrm>
             <a:off x="3884760" y="8685360"/>
-            <a:ext cx="2971440" cy="458280"/>
+            <a:ext cx="2971080" cy="457920"/>
           </a:xfrm>
           <a:prstGeom prst="rect">
             <a:avLst/>
@@ -515,6 +559,9 @@
                 <a:spcPct val="100000"/>
               </a:lnSpc>
               <a:buNone/>
+              <a:tabLst>
+                <a:tab algn="l" pos="0"/>
+              </a:tabLst>
               <a:defRPr lang="en-US" sz="1200" b="0" u="none" strike="noStrike">
                 <a:solidFill>
                   <a:schemeClr val="dk1"/>
@@ -532,8 +579,11 @@
                 <a:spcPct val="100000"/>
               </a:lnSpc>
               <a:buNone/>
-            </a:pPr>
-            <a:fld id="{EABB5714-03E2-480E-B9A9-4B9F9DCE9132}" type="slidenum">
+              <a:tabLst>
+                <a:tab algn="l" pos="0"/>
+              </a:tabLst>
+            </a:pPr>
+            <a:fld id="{E261839E-9F76-426D-994A-248B9797199D}" type="slidenum">
               <a:rPr lang="en-US" sz="1200" b="0" u="none" strike="noStrike">
                 <a:solidFill>
                   <a:schemeClr val="dk1"/>
@@ -591,7 +641,7 @@
         <p:spPr>
           <a:xfrm>
             <a:off x="685800" y="1143000"/>
-            <a:ext cx="5486040" cy="3085920"/>
+            <a:ext cx="5485680" cy="3085560"/>
           </a:xfrm>
           <a:prstGeom prst="rect">
             <a:avLst/>
@@ -614,7 +664,7 @@
         <p:spPr>
           <a:xfrm>
             <a:off x="685800" y="4400640"/>
-            <a:ext cx="5486040" cy="3600000"/>
+            <a:ext cx="5485680" cy="3599640"/>
           </a:xfrm>
           <a:prstGeom prst="rect">
             <a:avLst/>
@@ -656,7 +706,7 @@
         <p:spPr>
           <a:xfrm>
             <a:off x="3884760" y="8685360"/>
-            <a:ext cx="2971440" cy="458280"/>
+            <a:ext cx="2971080" cy="457920"/>
           </a:xfrm>
           <a:prstGeom prst="rect">
             <a:avLst/>
@@ -676,6 +726,9 @@
                 <a:spcPct val="100000"/>
               </a:lnSpc>
               <a:buNone/>
+              <a:tabLst>
+                <a:tab algn="l" pos="0"/>
+              </a:tabLst>
               <a:defRPr lang="en-US" sz="1200" b="0" u="none" strike="noStrike">
                 <a:solidFill>
                   <a:schemeClr val="dk1"/>
@@ -693,8 +746,11 @@
                 <a:spcPct val="100000"/>
               </a:lnSpc>
               <a:buNone/>
-            </a:pPr>
-            <a:fld id="{5B02BE72-705A-4459-AFDA-3778C5A9532F}" type="slidenum">
+              <a:tabLst>
+                <a:tab algn="l" pos="0"/>
+              </a:tabLst>
+            </a:pPr>
+            <a:fld id="{4F2F164E-24D7-4191-934A-B916155BD38D}" type="slidenum">
               <a:rPr lang="en-US" sz="1200" b="0" u="none" strike="noStrike">
                 <a:solidFill>
                   <a:schemeClr val="dk1"/>
@@ -752,7 +808,7 @@
         <p:spPr>
           <a:xfrm>
             <a:off x="685800" y="1143000"/>
-            <a:ext cx="5486040" cy="3085920"/>
+            <a:ext cx="5485680" cy="3085560"/>
           </a:xfrm>
           <a:prstGeom prst="rect">
             <a:avLst/>
@@ -775,7 +831,7 @@
         <p:spPr>
           <a:xfrm>
             <a:off x="685800" y="4400640"/>
-            <a:ext cx="5486040" cy="3600000"/>
+            <a:ext cx="5485680" cy="3599640"/>
           </a:xfrm>
           <a:prstGeom prst="rect">
             <a:avLst/>
@@ -817,7 +873,7 @@
         <p:spPr>
           <a:xfrm>
             <a:off x="3884760" y="8685360"/>
-            <a:ext cx="2971440" cy="458280"/>
+            <a:ext cx="2971080" cy="457920"/>
           </a:xfrm>
           <a:prstGeom prst="rect">
             <a:avLst/>
@@ -837,6 +893,9 @@
                 <a:spcPct val="100000"/>
               </a:lnSpc>
               <a:buNone/>
+              <a:tabLst>
+                <a:tab algn="l" pos="0"/>
+              </a:tabLst>
               <a:defRPr lang="en-US" sz="1200" b="0" u="none" strike="noStrike">
                 <a:solidFill>
                   <a:schemeClr val="dk1"/>
@@ -854,8 +913,11 @@
                 <a:spcPct val="100000"/>
               </a:lnSpc>
               <a:buNone/>
-            </a:pPr>
-            <a:fld id="{1320CEE0-2166-416A-906E-779D57F76E54}" type="slidenum">
+              <a:tabLst>
+                <a:tab algn="l" pos="0"/>
+              </a:tabLst>
+            </a:pPr>
+            <a:fld id="{EB2CE9D7-F6AD-4183-9B45-009406CE5468}" type="slidenum">
               <a:rPr lang="en-US" sz="1200" b="0" u="none" strike="noStrike">
                 <a:solidFill>
                   <a:schemeClr val="dk1"/>
@@ -913,7 +975,7 @@
         <p:spPr>
           <a:xfrm>
             <a:off x="685800" y="1143000"/>
-            <a:ext cx="5486040" cy="3085920"/>
+            <a:ext cx="5485680" cy="3085560"/>
           </a:xfrm>
           <a:prstGeom prst="rect">
             <a:avLst/>
@@ -936,7 +998,7 @@
         <p:spPr>
           <a:xfrm>
             <a:off x="685800" y="4400640"/>
-            <a:ext cx="5486040" cy="3600000"/>
+            <a:ext cx="5485680" cy="3599640"/>
           </a:xfrm>
           <a:prstGeom prst="rect">
             <a:avLst/>
@@ -978,7 +1040,7 @@
         <p:spPr>
           <a:xfrm>
             <a:off x="3884760" y="8685360"/>
-            <a:ext cx="2971440" cy="458280"/>
+            <a:ext cx="2971080" cy="457920"/>
           </a:xfrm>
           <a:prstGeom prst="rect">
             <a:avLst/>
@@ -998,6 +1060,9 @@
                 <a:spcPct val="100000"/>
               </a:lnSpc>
               <a:buNone/>
+              <a:tabLst>
+                <a:tab algn="l" pos="0"/>
+              </a:tabLst>
               <a:defRPr lang="en-US" sz="1200" b="0" u="none" strike="noStrike">
                 <a:solidFill>
                   <a:schemeClr val="dk1"/>
@@ -1015,8 +1080,11 @@
                 <a:spcPct val="100000"/>
               </a:lnSpc>
               <a:buNone/>
-            </a:pPr>
-            <a:fld id="{6D9B32BD-DDA1-4ECF-8617-E558F4449381}" type="slidenum">
+              <a:tabLst>
+                <a:tab algn="l" pos="0"/>
+              </a:tabLst>
+            </a:pPr>
+            <a:fld id="{185CDE13-BD21-4DF4-B16F-ACA6EB8E7981}" type="slidenum">
               <a:rPr lang="en-US" sz="1200" b="0" u="none" strike="noStrike">
                 <a:solidFill>
                   <a:schemeClr val="dk1"/>
@@ -1074,7 +1142,7 @@
         <p:spPr>
           <a:xfrm>
             <a:off x="685800" y="1143000"/>
-            <a:ext cx="5486040" cy="3085920"/>
+            <a:ext cx="5485680" cy="3085560"/>
           </a:xfrm>
           <a:prstGeom prst="rect">
             <a:avLst/>
@@ -1097,7 +1165,7 @@
         <p:spPr>
           <a:xfrm>
             <a:off x="685800" y="4400640"/>
-            <a:ext cx="5486040" cy="3600000"/>
+            <a:ext cx="5485680" cy="3599640"/>
           </a:xfrm>
           <a:prstGeom prst="rect">
             <a:avLst/>
@@ -1139,7 +1207,7 @@
         <p:spPr>
           <a:xfrm>
             <a:off x="3884760" y="8685360"/>
-            <a:ext cx="2971440" cy="458280"/>
+            <a:ext cx="2971080" cy="457920"/>
           </a:xfrm>
           <a:prstGeom prst="rect">
             <a:avLst/>
@@ -1159,6 +1227,9 @@
                 <a:spcPct val="100000"/>
               </a:lnSpc>
               <a:buNone/>
+              <a:tabLst>
+                <a:tab algn="l" pos="0"/>
+              </a:tabLst>
               <a:defRPr lang="en-US" sz="1200" b="0" u="none" strike="noStrike">
                 <a:solidFill>
                   <a:schemeClr val="dk1"/>
@@ -1176,8 +1247,11 @@
                 <a:spcPct val="100000"/>
               </a:lnSpc>
               <a:buNone/>
-            </a:pPr>
-            <a:fld id="{F836D048-3995-4DFD-B051-3CA602D7829C}" type="slidenum">
+              <a:tabLst>
+                <a:tab algn="l" pos="0"/>
+              </a:tabLst>
+            </a:pPr>
+            <a:fld id="{1E5ADDF2-125C-4358-A2FD-FAEDDE331729}" type="slidenum">
               <a:rPr lang="en-US" sz="1200" b="0" u="none" strike="noStrike">
                 <a:solidFill>
                   <a:schemeClr val="dk1"/>
@@ -1235,7 +1309,7 @@
         <p:spPr>
           <a:xfrm>
             <a:off x="685800" y="1143000"/>
-            <a:ext cx="5486040" cy="3085920"/>
+            <a:ext cx="5485680" cy="3085560"/>
           </a:xfrm>
           <a:prstGeom prst="rect">
             <a:avLst/>
@@ -1258,7 +1332,7 @@
         <p:spPr>
           <a:xfrm>
             <a:off x="685800" y="4400640"/>
-            <a:ext cx="5486040" cy="3600000"/>
+            <a:ext cx="5485680" cy="3599640"/>
           </a:xfrm>
           <a:prstGeom prst="rect">
             <a:avLst/>
@@ -1300,7 +1374,7 @@
         <p:spPr>
           <a:xfrm>
             <a:off x="3884760" y="8685360"/>
-            <a:ext cx="2971440" cy="458280"/>
+            <a:ext cx="2971080" cy="457920"/>
           </a:xfrm>
           <a:prstGeom prst="rect">
             <a:avLst/>
@@ -1320,6 +1394,9 @@
                 <a:spcPct val="100000"/>
               </a:lnSpc>
               <a:buNone/>
+              <a:tabLst>
+                <a:tab algn="l" pos="0"/>
+              </a:tabLst>
               <a:defRPr lang="en-US" sz="1200" b="0" u="none" strike="noStrike">
                 <a:solidFill>
                   <a:schemeClr val="dk1"/>
@@ -1337,8 +1414,11 @@
                 <a:spcPct val="100000"/>
               </a:lnSpc>
               <a:buNone/>
-            </a:pPr>
-            <a:fld id="{1DDF02D8-4F0A-46FA-8C91-FAC8EE51C4E6}" type="slidenum">
+              <a:tabLst>
+                <a:tab algn="l" pos="0"/>
+              </a:tabLst>
+            </a:pPr>
+            <a:fld id="{1B57E025-960D-4CF2-AC8B-17622B36AD75}" type="slidenum">
               <a:rPr lang="en-US" sz="1200" b="0" u="none" strike="noStrike">
                 <a:solidFill>
                   <a:schemeClr val="dk1"/>
@@ -1396,7 +1476,7 @@
         <p:spPr>
           <a:xfrm>
             <a:off x="685800" y="1143000"/>
-            <a:ext cx="5486040" cy="3085920"/>
+            <a:ext cx="5485680" cy="3085560"/>
           </a:xfrm>
           <a:prstGeom prst="rect">
             <a:avLst/>
@@ -1419,7 +1499,7 @@
         <p:spPr>
           <a:xfrm>
             <a:off x="685800" y="4400640"/>
-            <a:ext cx="5486040" cy="3600000"/>
+            <a:ext cx="5485680" cy="3599640"/>
           </a:xfrm>
           <a:prstGeom prst="rect">
             <a:avLst/>
@@ -1461,7 +1541,7 @@
         <p:spPr>
           <a:xfrm>
             <a:off x="3884760" y="8685360"/>
-            <a:ext cx="2971440" cy="458280"/>
+            <a:ext cx="2971080" cy="457920"/>
           </a:xfrm>
           <a:prstGeom prst="rect">
             <a:avLst/>
@@ -1481,6 +1561,9 @@
                 <a:spcPct val="100000"/>
               </a:lnSpc>
               <a:buNone/>
+              <a:tabLst>
+                <a:tab algn="l" pos="0"/>
+              </a:tabLst>
               <a:defRPr lang="en-US" sz="1200" b="0" u="none" strike="noStrike">
                 <a:solidFill>
                   <a:schemeClr val="dk1"/>
@@ -1498,8 +1581,11 @@
                 <a:spcPct val="100000"/>
               </a:lnSpc>
               <a:buNone/>
-            </a:pPr>
-            <a:fld id="{EFAC8129-05A2-49C6-B056-6FB820F63D8A}" type="slidenum">
+              <a:tabLst>
+                <a:tab algn="l" pos="0"/>
+              </a:tabLst>
+            </a:pPr>
+            <a:fld id="{F3306E7C-2886-4029-853D-C2732117CC84}" type="slidenum">
               <a:rPr lang="en-US" sz="1200" b="0" u="none" strike="noStrike">
                 <a:solidFill>
                   <a:schemeClr val="dk1"/>
@@ -1557,7 +1643,7 @@
         <p:spPr>
           <a:xfrm>
             <a:off x="685800" y="1143000"/>
-            <a:ext cx="5486040" cy="3085920"/>
+            <a:ext cx="5485680" cy="3085560"/>
           </a:xfrm>
           <a:prstGeom prst="rect">
             <a:avLst/>
@@ -1580,7 +1666,7 @@
         <p:spPr>
           <a:xfrm>
             <a:off x="685800" y="4400640"/>
-            <a:ext cx="5486040" cy="3600000"/>
+            <a:ext cx="5485680" cy="3599640"/>
           </a:xfrm>
           <a:prstGeom prst="rect">
             <a:avLst/>
@@ -1622,7 +1708,7 @@
         <p:spPr>
           <a:xfrm>
             <a:off x="3884760" y="8685360"/>
-            <a:ext cx="2971440" cy="458280"/>
+            <a:ext cx="2971080" cy="457920"/>
           </a:xfrm>
           <a:prstGeom prst="rect">
             <a:avLst/>
@@ -1642,6 +1728,9 @@
                 <a:spcPct val="100000"/>
               </a:lnSpc>
               <a:buNone/>
+              <a:tabLst>
+                <a:tab algn="l" pos="0"/>
+              </a:tabLst>
               <a:defRPr lang="en-US" sz="1200" b="0" u="none" strike="noStrike">
                 <a:solidFill>
                   <a:schemeClr val="dk1"/>
@@ -1659,8 +1748,11 @@
                 <a:spcPct val="100000"/>
               </a:lnSpc>
               <a:buNone/>
-            </a:pPr>
-            <a:fld id="{385DBAB5-E5BB-459E-AB89-FCBE19E26446}" type="slidenum">
+              <a:tabLst>
+                <a:tab algn="l" pos="0"/>
+              </a:tabLst>
+            </a:pPr>
+            <a:fld id="{D03DBAD7-77A2-42BE-A83B-0BD46BF59726}" type="slidenum">
               <a:rPr lang="en-US" sz="1200" b="0" u="none" strike="noStrike">
                 <a:solidFill>
                   <a:schemeClr val="dk1"/>
@@ -1670,7 +1762,7 @@
                 <a:latin typeface="+mn-lt"/>
                 <a:ea typeface="+mn-ea"/>
               </a:rPr>
-              <a:t>&lt;number&gt;</a:t>
+              <a:t>1</a:t>
             </a:fld>
             <a:endParaRPr lang="es-CO" sz="1200" b="0" u="none" strike="noStrike">
               <a:solidFill>
@@ -1762,27 +1854,27 @@
             <a:noAutofit/>
           </a:bodyPr>
           <a:p>
-            <a:pPr indent="0">
+            <a:pPr indent="0" algn="ctr">
               <a:buNone/>
             </a:pPr>
             <a:r>
-              <a:rPr lang="es-CO" sz="1800" b="0" u="none" strike="noStrike">
-                <a:solidFill>
-                  <a:schemeClr val="dk1"/>
-                </a:solidFill>
-                <a:effectLst/>
-                <a:uFillTx/>
-                <a:latin typeface="Calibri"/>
+              <a:rPr lang="es-CO" sz="4400" b="0" u="none" strike="noStrike">
+                <a:solidFill>
+                  <a:srgbClr val="000000"/>
+                </a:solidFill>
+                <a:effectLst/>
+                <a:uFillTx/>
+                <a:latin typeface="Arial"/>
               </a:rPr>
               <a:t>Click to edit the title text format</a:t>
             </a:r>
-            <a:endParaRPr lang="es-CO" sz="1800" b="0" u="none" strike="noStrike">
-              <a:solidFill>
-                <a:schemeClr val="dk1"/>
-              </a:solidFill>
-              <a:effectLst/>
-              <a:uFillTx/>
-              <a:latin typeface="Calibri"/>
+            <a:endParaRPr lang="es-CO" sz="4400" b="0" u="none" strike="noStrike">
+              <a:solidFill>
+                <a:srgbClr val="000000"/>
+              </a:solidFill>
+              <a:effectLst/>
+              <a:uFillTx/>
+              <a:latin typeface="Arial"/>
             </a:endParaRPr>
           </a:p>
         </p:txBody>
@@ -1812,7 +1904,7 @@
         </p:spPr>
         <p:txBody>
           <a:bodyPr lIns="0" rIns="0" tIns="0" bIns="0" anchor="t">
-            <a:normAutofit lnSpcReduction="9999"/>
+            <a:normAutofit/>
           </a:bodyPr>
           <a:p>
             <a:pPr marL="432000" indent="-324000">
@@ -1829,21 +1921,21 @@
             <a:r>
               <a:rPr lang="es-CO" sz="3200" b="0" u="none" strike="noStrike">
                 <a:solidFill>
-                  <a:schemeClr val="dk1"/>
-                </a:solidFill>
-                <a:effectLst/>
-                <a:uFillTx/>
-                <a:latin typeface="Calibri"/>
+                  <a:srgbClr val="000000"/>
+                </a:solidFill>
+                <a:effectLst/>
+                <a:uFillTx/>
+                <a:latin typeface="Arial"/>
               </a:rPr>
               <a:t>Click to edit the outline text format</a:t>
             </a:r>
             <a:endParaRPr lang="es-CO" sz="3200" b="0" u="none" strike="noStrike">
               <a:solidFill>
-                <a:schemeClr val="dk1"/>
-              </a:solidFill>
-              <a:effectLst/>
-              <a:uFillTx/>
-              <a:latin typeface="Calibri"/>
+                <a:srgbClr val="000000"/>
+              </a:solidFill>
+              <a:effectLst/>
+              <a:uFillTx/>
+              <a:latin typeface="Arial"/>
             </a:endParaRPr>
           </a:p>
           <a:p>
@@ -1859,23 +1951,23 @@
               <a:buChar char=""/>
             </a:pPr>
             <a:r>
-              <a:rPr lang="es-CO" sz="2400" b="0" u="none" strike="noStrike">
-                <a:solidFill>
-                  <a:schemeClr val="dk1"/>
-                </a:solidFill>
-                <a:effectLst/>
-                <a:uFillTx/>
-                <a:latin typeface="Calibri"/>
+              <a:rPr lang="es-CO" sz="2800" b="0" u="none" strike="noStrike">
+                <a:solidFill>
+                  <a:srgbClr val="000000"/>
+                </a:solidFill>
+                <a:effectLst/>
+                <a:uFillTx/>
+                <a:latin typeface="Arial"/>
               </a:rPr>
               <a:t>Second Outline Level</a:t>
             </a:r>
-            <a:endParaRPr lang="es-CO" sz="2400" b="0" u="none" strike="noStrike">
-              <a:solidFill>
-                <a:schemeClr val="dk1"/>
-              </a:solidFill>
-              <a:effectLst/>
-              <a:uFillTx/>
-              <a:latin typeface="Calibri"/>
+            <a:endParaRPr lang="es-CO" sz="2800" b="0" u="none" strike="noStrike">
+              <a:solidFill>
+                <a:srgbClr val="000000"/>
+              </a:solidFill>
+              <a:effectLst/>
+              <a:uFillTx/>
+              <a:latin typeface="Arial"/>
             </a:endParaRPr>
           </a:p>
           <a:p>
@@ -1891,23 +1983,23 @@
               <a:buChar char=""/>
             </a:pPr>
             <a:r>
-              <a:rPr lang="es-CO" sz="2000" b="0" u="none" strike="noStrike">
-                <a:solidFill>
-                  <a:schemeClr val="dk1"/>
-                </a:solidFill>
-                <a:effectLst/>
-                <a:uFillTx/>
-                <a:latin typeface="Calibri"/>
+              <a:rPr lang="es-CO" sz="2400" b="0" u="none" strike="noStrike">
+                <a:solidFill>
+                  <a:srgbClr val="000000"/>
+                </a:solidFill>
+                <a:effectLst/>
+                <a:uFillTx/>
+                <a:latin typeface="Arial"/>
               </a:rPr>
               <a:t>Third Outline Level</a:t>
             </a:r>
-            <a:endParaRPr lang="es-CO" sz="2000" b="0" u="none" strike="noStrike">
-              <a:solidFill>
-                <a:schemeClr val="dk1"/>
-              </a:solidFill>
-              <a:effectLst/>
-              <a:uFillTx/>
-              <a:latin typeface="Calibri"/>
+            <a:endParaRPr lang="es-CO" sz="2400" b="0" u="none" strike="noStrike">
+              <a:solidFill>
+                <a:srgbClr val="000000"/>
+              </a:solidFill>
+              <a:effectLst/>
+              <a:uFillTx/>
+              <a:latin typeface="Arial"/>
             </a:endParaRPr>
           </a:p>
           <a:p>
@@ -1925,21 +2017,21 @@
             <a:r>
               <a:rPr lang="es-CO" sz="2000" b="0" u="none" strike="noStrike">
                 <a:solidFill>
-                  <a:schemeClr val="dk1"/>
-                </a:solidFill>
-                <a:effectLst/>
-                <a:uFillTx/>
-                <a:latin typeface="Calibri"/>
+                  <a:srgbClr val="000000"/>
+                </a:solidFill>
+                <a:effectLst/>
+                <a:uFillTx/>
+                <a:latin typeface="Arial"/>
               </a:rPr>
               <a:t>Fourth Outline Level</a:t>
             </a:r>
             <a:endParaRPr lang="es-CO" sz="2000" b="0" u="none" strike="noStrike">
               <a:solidFill>
-                <a:schemeClr val="dk1"/>
-              </a:solidFill>
-              <a:effectLst/>
-              <a:uFillTx/>
-              <a:latin typeface="Calibri"/>
+                <a:srgbClr val="000000"/>
+              </a:solidFill>
+              <a:effectLst/>
+              <a:uFillTx/>
+              <a:latin typeface="Arial"/>
             </a:endParaRPr>
           </a:p>
           <a:p>
@@ -1957,21 +2049,21 @@
             <a:r>
               <a:rPr lang="es-CO" sz="2000" b="0" u="none" strike="noStrike">
                 <a:solidFill>
-                  <a:schemeClr val="dk1"/>
-                </a:solidFill>
-                <a:effectLst/>
-                <a:uFillTx/>
-                <a:latin typeface="Calibri"/>
+                  <a:srgbClr val="000000"/>
+                </a:solidFill>
+                <a:effectLst/>
+                <a:uFillTx/>
+                <a:latin typeface="Arial"/>
               </a:rPr>
               <a:t>Fifth Outline Level</a:t>
             </a:r>
             <a:endParaRPr lang="es-CO" sz="2000" b="0" u="none" strike="noStrike">
               <a:solidFill>
-                <a:schemeClr val="dk1"/>
-              </a:solidFill>
-              <a:effectLst/>
-              <a:uFillTx/>
-              <a:latin typeface="Calibri"/>
+                <a:srgbClr val="000000"/>
+              </a:solidFill>
+              <a:effectLst/>
+              <a:uFillTx/>
+              <a:latin typeface="Arial"/>
             </a:endParaRPr>
           </a:p>
           <a:p>
@@ -1989,21 +2081,21 @@
             <a:r>
               <a:rPr lang="es-CO" sz="2000" b="0" u="none" strike="noStrike">
                 <a:solidFill>
-                  <a:schemeClr val="dk1"/>
-                </a:solidFill>
-                <a:effectLst/>
-                <a:uFillTx/>
-                <a:latin typeface="Calibri"/>
+                  <a:srgbClr val="000000"/>
+                </a:solidFill>
+                <a:effectLst/>
+                <a:uFillTx/>
+                <a:latin typeface="Arial"/>
               </a:rPr>
               <a:t>Sixth Outline Level</a:t>
             </a:r>
             <a:endParaRPr lang="es-CO" sz="2000" b="0" u="none" strike="noStrike">
               <a:solidFill>
-                <a:schemeClr val="dk1"/>
-              </a:solidFill>
-              <a:effectLst/>
-              <a:uFillTx/>
-              <a:latin typeface="Calibri"/>
+                <a:srgbClr val="000000"/>
+              </a:solidFill>
+              <a:effectLst/>
+              <a:uFillTx/>
+              <a:latin typeface="Arial"/>
             </a:endParaRPr>
           </a:p>
           <a:p>
@@ -2021,21 +2113,21 @@
             <a:r>
               <a:rPr lang="es-CO" sz="2000" b="0" u="none" strike="noStrike">
                 <a:solidFill>
-                  <a:schemeClr val="dk1"/>
-                </a:solidFill>
-                <a:effectLst/>
-                <a:uFillTx/>
-                <a:latin typeface="Calibri"/>
+                  <a:srgbClr val="000000"/>
+                </a:solidFill>
+                <a:effectLst/>
+                <a:uFillTx/>
+                <a:latin typeface="Arial"/>
               </a:rPr>
               <a:t>Seventh Outline Level</a:t>
             </a:r>
             <a:endParaRPr lang="es-CO" sz="2000" b="0" u="none" strike="noStrike">
               <a:solidFill>
-                <a:schemeClr val="dk1"/>
-              </a:solidFill>
-              <a:effectLst/>
-              <a:uFillTx/>
-              <a:latin typeface="Calibri"/>
+                <a:srgbClr val="000000"/>
+              </a:solidFill>
+              <a:effectLst/>
+              <a:uFillTx/>
+              <a:latin typeface="Arial"/>
             </a:endParaRPr>
           </a:p>
         </p:txBody>
@@ -2082,7 +2174,7 @@
         <p:spPr>
           <a:xfrm>
             <a:off x="0" y="0"/>
-            <a:ext cx="164160" cy="5143320"/>
+            <a:ext cx="163800" cy="5142960"/>
           </a:xfrm>
           <a:prstGeom prst="rect">
             <a:avLst/>
@@ -2108,6 +2200,11 @@
             <a:noAutofit/>
           </a:bodyPr>
           <a:p>
+            <a:pPr>
+              <a:lnSpc>
+                <a:spcPct val="100000"/>
+              </a:lnSpc>
+            </a:pPr>
             <a:endParaRPr lang="es-CO" sz="1800" b="0" u="none" strike="noStrike">
               <a:solidFill>
                 <a:srgbClr val="ffffff"/>
@@ -2128,7 +2225,7 @@
         <p:spPr>
           <a:xfrm>
             <a:off x="164520" y="0"/>
-            <a:ext cx="54360" cy="5143320"/>
+            <a:ext cx="54000" cy="5142960"/>
           </a:xfrm>
           <a:prstGeom prst="rect">
             <a:avLst/>
@@ -2154,6 +2251,11 @@
             <a:noAutofit/>
           </a:bodyPr>
           <a:p>
+            <a:pPr>
+              <a:lnSpc>
+                <a:spcPct val="100000"/>
+              </a:lnSpc>
+            </a:pPr>
             <a:endParaRPr lang="es-CO" sz="1800" b="0" u="none" strike="noStrike">
               <a:solidFill>
                 <a:srgbClr val="ffffff"/>
@@ -2174,7 +2276,7 @@
         <p:spPr>
           <a:xfrm>
             <a:off x="640080" y="502920"/>
-            <a:ext cx="2599920" cy="347040"/>
+            <a:ext cx="2599560" cy="346680"/>
           </a:xfrm>
           <a:prstGeom prst="roundRect">
             <a:avLst>
@@ -2204,6 +2306,11 @@
             <a:noAutofit/>
           </a:bodyPr>
           <a:p>
+            <a:pPr>
+              <a:lnSpc>
+                <a:spcPct val="100000"/>
+              </a:lnSpc>
+            </a:pPr>
             <a:endParaRPr lang="es-CO" sz="1800" b="0" u="none" strike="noStrike">
               <a:solidFill>
                 <a:srgbClr val="ffffff"/>
@@ -2224,7 +2331,7 @@
         <p:spPr>
           <a:xfrm>
             <a:off x="640080" y="502920"/>
-            <a:ext cx="2559960" cy="347040"/>
+            <a:ext cx="2559600" cy="346680"/>
           </a:xfrm>
           <a:prstGeom prst="rect">
             <a:avLst/>
@@ -2284,7 +2391,7 @@
         <p:spPr>
           <a:xfrm>
             <a:off x="640080" y="1097280"/>
-            <a:ext cx="8229240" cy="914040"/>
+            <a:ext cx="8228880" cy="913680"/>
           </a:xfrm>
           <a:prstGeom prst="rect">
             <a:avLst/>
@@ -2345,7 +2452,7 @@
         <p:spPr>
           <a:xfrm>
             <a:off x="640080" y="1920240"/>
-            <a:ext cx="8229240" cy="685440"/>
+            <a:ext cx="8228880" cy="685080"/>
           </a:xfrm>
           <a:prstGeom prst="rect">
             <a:avLst/>
@@ -2406,7 +2513,7 @@
         <p:spPr>
           <a:xfrm>
             <a:off x="640080" y="2788920"/>
-            <a:ext cx="6857640" cy="822600"/>
+            <a:ext cx="6857280" cy="822240"/>
           </a:xfrm>
           <a:prstGeom prst="rect">
             <a:avLst/>
@@ -2540,7 +2647,7 @@
         <p:spPr>
           <a:xfrm>
             <a:off x="640080" y="3840480"/>
-            <a:ext cx="8229240" cy="319680"/>
+            <a:ext cx="8228880" cy="319320"/>
           </a:xfrm>
           <a:prstGeom prst="rect">
             <a:avLst/>
@@ -2601,7 +2708,7 @@
         <p:spPr>
           <a:xfrm>
             <a:off x="640080" y="4206240"/>
-            <a:ext cx="8229240" cy="319680"/>
+            <a:ext cx="8228880" cy="319320"/>
           </a:xfrm>
           <a:prstGeom prst="rect">
             <a:avLst/>
@@ -2699,7 +2806,7 @@
         <p:spPr>
           <a:xfrm>
             <a:off x="0" y="0"/>
-            <a:ext cx="109440" cy="5143320"/>
+            <a:ext cx="109080" cy="5142960"/>
           </a:xfrm>
           <a:prstGeom prst="rect">
             <a:avLst/>
@@ -2725,6 +2832,11 @@
             <a:noAutofit/>
           </a:bodyPr>
           <a:p>
+            <a:pPr>
+              <a:lnSpc>
+                <a:spcPct val="100000"/>
+              </a:lnSpc>
+            </a:pPr>
             <a:endParaRPr lang="es-CO" sz="1800" b="0" u="none" strike="noStrike">
               <a:solidFill>
                 <a:srgbClr val="ffffff"/>
@@ -2745,7 +2857,7 @@
         <p:spPr>
           <a:xfrm>
             <a:off x="365760" y="274320"/>
-            <a:ext cx="8503560" cy="639720"/>
+            <a:ext cx="8503200" cy="639360"/>
           </a:xfrm>
           <a:prstGeom prst="rect">
             <a:avLst/>
@@ -2806,7 +2918,7 @@
         <p:spPr>
           <a:xfrm>
             <a:off x="365760" y="1051560"/>
-            <a:ext cx="8412120" cy="776880"/>
+            <a:ext cx="8411760" cy="776520"/>
           </a:xfrm>
           <a:prstGeom prst="rect">
             <a:avLst/>
@@ -2867,7 +2979,7 @@
         <p:spPr>
           <a:xfrm>
             <a:off x="365760" y="1920240"/>
-            <a:ext cx="8412120" cy="685440"/>
+            <a:ext cx="8411760" cy="685080"/>
           </a:xfrm>
           <a:prstGeom prst="rect">
             <a:avLst/>
@@ -2902,6 +3014,11 @@
             <a:noAutofit/>
           </a:bodyPr>
           <a:p>
+            <a:pPr>
+              <a:lnSpc>
+                <a:spcPct val="100000"/>
+              </a:lnSpc>
+            </a:pPr>
             <a:endParaRPr lang="es-CO" sz="1800" b="0" u="none" strike="noStrike">
               <a:solidFill>
                 <a:srgbClr val="ffffff"/>
@@ -2922,7 +3039,7 @@
         <p:spPr>
           <a:xfrm>
             <a:off x="365760" y="1920240"/>
-            <a:ext cx="54360" cy="685440"/>
+            <a:ext cx="54000" cy="685080"/>
           </a:xfrm>
           <a:prstGeom prst="rect">
             <a:avLst/>
@@ -2948,6 +3065,11 @@
             <a:noAutofit/>
           </a:bodyPr>
           <a:p>
+            <a:pPr>
+              <a:lnSpc>
+                <a:spcPct val="100000"/>
+              </a:lnSpc>
+            </a:pPr>
             <a:endParaRPr lang="es-CO" sz="1800" b="0" u="none" strike="noStrike">
               <a:solidFill>
                 <a:srgbClr val="ffffff"/>
@@ -2968,7 +3090,7 @@
         <p:spPr>
           <a:xfrm>
             <a:off x="548640" y="1920240"/>
-            <a:ext cx="8229240" cy="685440"/>
+            <a:ext cx="8228880" cy="685080"/>
           </a:xfrm>
           <a:prstGeom prst="rect">
             <a:avLst/>
@@ -3029,7 +3151,7 @@
         <p:spPr>
           <a:xfrm>
             <a:off x="365760" y="2788920"/>
-            <a:ext cx="2605680" cy="1325520"/>
+            <a:ext cx="2605320" cy="1325160"/>
           </a:xfrm>
           <a:prstGeom prst="rect">
             <a:avLst/>
@@ -3062,6 +3184,11 @@
             <a:noAutofit/>
           </a:bodyPr>
           <a:p>
+            <a:pPr>
+              <a:lnSpc>
+                <a:spcPct val="100000"/>
+              </a:lnSpc>
+            </a:pPr>
             <a:endParaRPr lang="es-CO" sz="1800" b="0" u="none" strike="noStrike">
               <a:solidFill>
                 <a:srgbClr val="000000"/>
@@ -3082,7 +3209,7 @@
         <p:spPr>
           <a:xfrm>
             <a:off x="365760" y="2788920"/>
-            <a:ext cx="2605680" cy="45360"/>
+            <a:ext cx="2605320" cy="45000"/>
           </a:xfrm>
           <a:prstGeom prst="rect">
             <a:avLst/>
@@ -3108,6 +3235,11 @@
             <a:noAutofit/>
           </a:bodyPr>
           <a:p>
+            <a:pPr>
+              <a:lnSpc>
+                <a:spcPct val="100000"/>
+              </a:lnSpc>
+            </a:pPr>
             <a:endParaRPr lang="es-CO" sz="1800" b="0" u="none" strike="noStrike">
               <a:solidFill>
                 <a:srgbClr val="ffffff"/>
@@ -3128,7 +3260,7 @@
         <p:spPr>
           <a:xfrm>
             <a:off x="365760" y="2898720"/>
-            <a:ext cx="2605680" cy="411120"/>
+            <a:ext cx="2605320" cy="410760"/>
           </a:xfrm>
           <a:prstGeom prst="rect">
             <a:avLst/>
@@ -3188,7 +3320,7 @@
         <p:spPr>
           <a:xfrm>
             <a:off x="365760" y="3291840"/>
-            <a:ext cx="2605680" cy="273960"/>
+            <a:ext cx="2605320" cy="273600"/>
           </a:xfrm>
           <a:prstGeom prst="rect">
             <a:avLst/>
@@ -3249,7 +3381,7 @@
         <p:spPr>
           <a:xfrm>
             <a:off x="365760" y="3566160"/>
-            <a:ext cx="2605680" cy="456840"/>
+            <a:ext cx="2605320" cy="456480"/>
           </a:xfrm>
           <a:prstGeom prst="rect">
             <a:avLst/>
@@ -3340,7 +3472,7 @@
         <p:spPr>
           <a:xfrm>
             <a:off x="3127320" y="2788920"/>
-            <a:ext cx="2605680" cy="1325520"/>
+            <a:ext cx="2605320" cy="1325160"/>
           </a:xfrm>
           <a:prstGeom prst="rect">
             <a:avLst/>
@@ -3373,6 +3505,11 @@
             <a:noAutofit/>
           </a:bodyPr>
           <a:p>
+            <a:pPr>
+              <a:lnSpc>
+                <a:spcPct val="100000"/>
+              </a:lnSpc>
+            </a:pPr>
             <a:endParaRPr lang="es-CO" sz="1800" b="0" u="none" strike="noStrike">
               <a:solidFill>
                 <a:srgbClr val="000000"/>
@@ -3393,7 +3530,7 @@
         <p:spPr>
           <a:xfrm>
             <a:off x="3127320" y="2788920"/>
-            <a:ext cx="2605680" cy="45360"/>
+            <a:ext cx="2605320" cy="45000"/>
           </a:xfrm>
           <a:prstGeom prst="rect">
             <a:avLst/>
@@ -3419,6 +3556,11 @@
             <a:noAutofit/>
           </a:bodyPr>
           <a:p>
+            <a:pPr>
+              <a:lnSpc>
+                <a:spcPct val="100000"/>
+              </a:lnSpc>
+            </a:pPr>
             <a:endParaRPr lang="es-CO" sz="1800" b="0" u="none" strike="noStrike">
               <a:solidFill>
                 <a:srgbClr val="ffffff"/>
@@ -3439,7 +3581,7 @@
         <p:spPr>
           <a:xfrm>
             <a:off x="3127320" y="2898720"/>
-            <a:ext cx="2605680" cy="411120"/>
+            <a:ext cx="2605320" cy="410760"/>
           </a:xfrm>
           <a:prstGeom prst="rect">
             <a:avLst/>
@@ -3499,7 +3641,7 @@
         <p:spPr>
           <a:xfrm>
             <a:off x="3127320" y="3291840"/>
-            <a:ext cx="2605680" cy="273960"/>
+            <a:ext cx="2605320" cy="273600"/>
           </a:xfrm>
           <a:prstGeom prst="rect">
             <a:avLst/>
@@ -3560,7 +3702,7 @@
         <p:spPr>
           <a:xfrm>
             <a:off x="3127320" y="3566160"/>
-            <a:ext cx="2605680" cy="456840"/>
+            <a:ext cx="2605320" cy="456480"/>
           </a:xfrm>
           <a:prstGeom prst="rect">
             <a:avLst/>
@@ -3651,7 +3793,7 @@
         <p:spPr>
           <a:xfrm>
             <a:off x="5888880" y="2788920"/>
-            <a:ext cx="2605680" cy="1325520"/>
+            <a:ext cx="2605320" cy="1325160"/>
           </a:xfrm>
           <a:prstGeom prst="rect">
             <a:avLst/>
@@ -3684,6 +3826,11 @@
             <a:noAutofit/>
           </a:bodyPr>
           <a:p>
+            <a:pPr>
+              <a:lnSpc>
+                <a:spcPct val="100000"/>
+              </a:lnSpc>
+            </a:pPr>
             <a:endParaRPr lang="es-CO" sz="1800" b="0" u="none" strike="noStrike">
               <a:solidFill>
                 <a:srgbClr val="000000"/>
@@ -3704,7 +3851,7 @@
         <p:spPr>
           <a:xfrm>
             <a:off x="5888880" y="2788920"/>
-            <a:ext cx="2605680" cy="45360"/>
+            <a:ext cx="2605320" cy="45000"/>
           </a:xfrm>
           <a:prstGeom prst="rect">
             <a:avLst/>
@@ -3730,6 +3877,11 @@
             <a:noAutofit/>
           </a:bodyPr>
           <a:p>
+            <a:pPr>
+              <a:lnSpc>
+                <a:spcPct val="100000"/>
+              </a:lnSpc>
+            </a:pPr>
             <a:endParaRPr lang="es-CO" sz="1800" b="0" u="none" strike="noStrike">
               <a:solidFill>
                 <a:srgbClr val="ffffff"/>
@@ -3750,7 +3902,7 @@
         <p:spPr>
           <a:xfrm>
             <a:off x="5888880" y="2898720"/>
-            <a:ext cx="2605680" cy="411120"/>
+            <a:ext cx="2605320" cy="410760"/>
           </a:xfrm>
           <a:prstGeom prst="rect">
             <a:avLst/>
@@ -3810,7 +3962,7 @@
         <p:spPr>
           <a:xfrm>
             <a:off x="5888880" y="3291840"/>
-            <a:ext cx="2605680" cy="273960"/>
+            <a:ext cx="2605320" cy="273600"/>
           </a:xfrm>
           <a:prstGeom prst="rect">
             <a:avLst/>
@@ -3871,7 +4023,7 @@
         <p:spPr>
           <a:xfrm>
             <a:off x="5888880" y="3566160"/>
-            <a:ext cx="2605680" cy="456840"/>
+            <a:ext cx="2605320" cy="456480"/>
           </a:xfrm>
           <a:prstGeom prst="rect">
             <a:avLst/>
@@ -3999,7 +4151,7 @@
         <p:spPr>
           <a:xfrm>
             <a:off x="0" y="0"/>
-            <a:ext cx="109440" cy="5143320"/>
+            <a:ext cx="109080" cy="5142960"/>
           </a:xfrm>
           <a:prstGeom prst="rect">
             <a:avLst/>
@@ -4025,6 +4177,11 @@
             <a:noAutofit/>
           </a:bodyPr>
           <a:p>
+            <a:pPr>
+              <a:lnSpc>
+                <a:spcPct val="100000"/>
+              </a:lnSpc>
+            </a:pPr>
             <a:endParaRPr lang="es-CO" sz="1800" b="0" u="none" strike="noStrike">
               <a:solidFill>
                 <a:srgbClr val="ffffff"/>
@@ -4045,7 +4202,7 @@
         <p:spPr>
           <a:xfrm>
             <a:off x="365760" y="274320"/>
-            <a:ext cx="8503560" cy="594000"/>
+            <a:ext cx="8503200" cy="593640"/>
           </a:xfrm>
           <a:prstGeom prst="rect">
             <a:avLst/>
@@ -4106,7 +4263,7 @@
         <p:spPr>
           <a:xfrm>
             <a:off x="365760" y="868680"/>
-            <a:ext cx="8503560" cy="319680"/>
+            <a:ext cx="8503200" cy="319320"/>
           </a:xfrm>
           <a:prstGeom prst="rect">
             <a:avLst/>
@@ -4167,7 +4324,7 @@
         <p:spPr>
           <a:xfrm>
             <a:off x="365760" y="1371600"/>
-            <a:ext cx="2011320" cy="2331360"/>
+            <a:ext cx="2010960" cy="2331000"/>
           </a:xfrm>
           <a:prstGeom prst="rect">
             <a:avLst/>
@@ -4200,6 +4357,11 @@
             <a:noAutofit/>
           </a:bodyPr>
           <a:p>
+            <a:pPr>
+              <a:lnSpc>
+                <a:spcPct val="100000"/>
+              </a:lnSpc>
+            </a:pPr>
             <a:endParaRPr lang="es-CO" sz="1800" b="0" u="none" strike="noStrike">
               <a:solidFill>
                 <a:srgbClr val="000000"/>
@@ -4220,7 +4382,7 @@
         <p:spPr>
           <a:xfrm>
             <a:off x="365760" y="1371600"/>
-            <a:ext cx="2011320" cy="502560"/>
+            <a:ext cx="2010960" cy="502200"/>
           </a:xfrm>
           <a:prstGeom prst="rect">
             <a:avLst/>
@@ -4246,6 +4408,11 @@
             <a:noAutofit/>
           </a:bodyPr>
           <a:p>
+            <a:pPr>
+              <a:lnSpc>
+                <a:spcPct val="100000"/>
+              </a:lnSpc>
+            </a:pPr>
             <a:endParaRPr lang="es-CO" sz="1800" b="0" u="none" strike="noStrike">
               <a:solidFill>
                 <a:srgbClr val="ffffff"/>
@@ -4266,7 +4433,7 @@
         <p:spPr>
           <a:xfrm>
             <a:off x="365760" y="1371600"/>
-            <a:ext cx="2011320" cy="502560"/>
+            <a:ext cx="2010960" cy="502200"/>
           </a:xfrm>
           <a:prstGeom prst="rect">
             <a:avLst/>
@@ -4327,7 +4494,7 @@
         <p:spPr>
           <a:xfrm>
             <a:off x="365760" y="1901880"/>
-            <a:ext cx="2011320" cy="319680"/>
+            <a:ext cx="2010960" cy="319320"/>
           </a:xfrm>
           <a:prstGeom prst="rect">
             <a:avLst/>
@@ -4366,7 +4533,7 @@
                 <a:latin typeface="Consolas"/>
                 <a:ea typeface="Consolas"/>
               </a:rPr>
-              <a:t>01_i ngestion_ETL.i pynb</a:t>
+              <a:t>01_ingestion_ETL.i pynb</a:t>
             </a:r>
             <a:endParaRPr lang="es-CO" sz="800" b="0" u="none" strike="noStrike">
               <a:solidFill>
@@ -4388,7 +4555,7 @@
         <p:spPr>
           <a:xfrm>
             <a:off x="365760" y="2212920"/>
-            <a:ext cx="2011320" cy="456840"/>
+            <a:ext cx="2010960" cy="456480"/>
           </a:xfrm>
           <a:prstGeom prst="rect">
             <a:avLst/>
@@ -4449,7 +4616,7 @@
         <p:spPr>
           <a:xfrm>
             <a:off x="457200" y="2688480"/>
-            <a:ext cx="1828440" cy="914040"/>
+            <a:ext cx="1828080" cy="913680"/>
           </a:xfrm>
           <a:prstGeom prst="rect">
             <a:avLst/>
@@ -4540,7 +4707,7 @@
         <p:spPr>
           <a:xfrm>
             <a:off x="2496240" y="1371600"/>
-            <a:ext cx="2011320" cy="2331360"/>
+            <a:ext cx="2010960" cy="2331000"/>
           </a:xfrm>
           <a:prstGeom prst="rect">
             <a:avLst/>
@@ -4573,6 +4740,11 @@
             <a:noAutofit/>
           </a:bodyPr>
           <a:p>
+            <a:pPr>
+              <a:lnSpc>
+                <a:spcPct val="100000"/>
+              </a:lnSpc>
+            </a:pPr>
             <a:endParaRPr lang="es-CO" sz="1800" b="0" u="none" strike="noStrike">
               <a:solidFill>
                 <a:srgbClr val="000000"/>
@@ -4593,7 +4765,7 @@
         <p:spPr>
           <a:xfrm>
             <a:off x="2496240" y="1371600"/>
-            <a:ext cx="2011320" cy="502560"/>
+            <a:ext cx="2010960" cy="502200"/>
           </a:xfrm>
           <a:prstGeom prst="rect">
             <a:avLst/>
@@ -4619,6 +4791,11 @@
             <a:noAutofit/>
           </a:bodyPr>
           <a:p>
+            <a:pPr>
+              <a:lnSpc>
+                <a:spcPct val="100000"/>
+              </a:lnSpc>
+            </a:pPr>
             <a:endParaRPr lang="es-CO" sz="1800" b="0" u="none" strike="noStrike">
               <a:solidFill>
                 <a:srgbClr val="ffffff"/>
@@ -4639,7 +4816,7 @@
         <p:spPr>
           <a:xfrm>
             <a:off x="2496240" y="1371600"/>
-            <a:ext cx="2011320" cy="502560"/>
+            <a:ext cx="2010960" cy="502200"/>
           </a:xfrm>
           <a:prstGeom prst="rect">
             <a:avLst/>
@@ -4700,7 +4877,7 @@
         <p:spPr>
           <a:xfrm>
             <a:off x="2496240" y="1901880"/>
-            <a:ext cx="2011320" cy="319680"/>
+            <a:ext cx="2010960" cy="319320"/>
           </a:xfrm>
           <a:prstGeom prst="rect">
             <a:avLst/>
@@ -4739,7 +4916,7 @@
                 <a:latin typeface="Consolas"/>
                 <a:ea typeface="Consolas"/>
               </a:rPr>
-              <a:t>02_data_qa_l ayer.i pynb</a:t>
+              <a:t>02_data_qa_layer.ipynb</a:t>
             </a:r>
             <a:endParaRPr lang="es-CO" sz="800" b="0" u="none" strike="noStrike">
               <a:solidFill>
@@ -4761,7 +4938,7 @@
         <p:spPr>
           <a:xfrm>
             <a:off x="2496240" y="2212920"/>
-            <a:ext cx="2011320" cy="456840"/>
+            <a:ext cx="2010960" cy="456480"/>
           </a:xfrm>
           <a:prstGeom prst="rect">
             <a:avLst/>
@@ -4822,7 +4999,7 @@
         <p:spPr>
           <a:xfrm>
             <a:off x="2587680" y="2688480"/>
-            <a:ext cx="1828440" cy="914040"/>
+            <a:ext cx="1828080" cy="913680"/>
           </a:xfrm>
           <a:prstGeom prst="rect">
             <a:avLst/>
@@ -4913,7 +5090,7 @@
         <p:spPr>
           <a:xfrm>
             <a:off x="4626720" y="1371600"/>
-            <a:ext cx="2011320" cy="2331360"/>
+            <a:ext cx="2010960" cy="2331000"/>
           </a:xfrm>
           <a:prstGeom prst="rect">
             <a:avLst/>
@@ -4946,6 +5123,11 @@
             <a:noAutofit/>
           </a:bodyPr>
           <a:p>
+            <a:pPr>
+              <a:lnSpc>
+                <a:spcPct val="100000"/>
+              </a:lnSpc>
+            </a:pPr>
             <a:endParaRPr lang="es-CO" sz="1800" b="0" u="none" strike="noStrike">
               <a:solidFill>
                 <a:srgbClr val="000000"/>
@@ -4966,7 +5148,7 @@
         <p:spPr>
           <a:xfrm>
             <a:off x="4626720" y="1371600"/>
-            <a:ext cx="2011320" cy="502560"/>
+            <a:ext cx="2010960" cy="502200"/>
           </a:xfrm>
           <a:prstGeom prst="rect">
             <a:avLst/>
@@ -4992,6 +5174,11 @@
             <a:noAutofit/>
           </a:bodyPr>
           <a:p>
+            <a:pPr>
+              <a:lnSpc>
+                <a:spcPct val="100000"/>
+              </a:lnSpc>
+            </a:pPr>
             <a:endParaRPr lang="es-CO" sz="1800" b="0" u="none" strike="noStrike">
               <a:solidFill>
                 <a:srgbClr val="ffffff"/>
@@ -5012,7 +5199,7 @@
         <p:spPr>
           <a:xfrm>
             <a:off x="4626720" y="1371600"/>
-            <a:ext cx="2011320" cy="502560"/>
+            <a:ext cx="2010960" cy="502200"/>
           </a:xfrm>
           <a:prstGeom prst="rect">
             <a:avLst/>
@@ -5073,7 +5260,7 @@
         <p:spPr>
           <a:xfrm>
             <a:off x="4626720" y="1901880"/>
-            <a:ext cx="2011320" cy="319680"/>
+            <a:ext cx="2010960" cy="319320"/>
           </a:xfrm>
           <a:prstGeom prst="rect">
             <a:avLst/>
@@ -5112,7 +5299,7 @@
                 <a:latin typeface="Consolas"/>
                 <a:ea typeface="Consolas"/>
               </a:rPr>
-              <a:t>03_eda.i pynb</a:t>
+              <a:t>03_eda.ipynb</a:t>
             </a:r>
             <a:endParaRPr lang="es-CO" sz="800" b="0" u="none" strike="noStrike">
               <a:solidFill>
@@ -5134,7 +5321,7 @@
         <p:spPr>
           <a:xfrm>
             <a:off x="4626720" y="2212920"/>
-            <a:ext cx="2011320" cy="456840"/>
+            <a:ext cx="2010960" cy="456480"/>
           </a:xfrm>
           <a:prstGeom prst="rect">
             <a:avLst/>
@@ -5195,7 +5382,7 @@
         <p:spPr>
           <a:xfrm>
             <a:off x="4718160" y="2688480"/>
-            <a:ext cx="1828440" cy="914040"/>
+            <a:ext cx="1828080" cy="913680"/>
           </a:xfrm>
           <a:prstGeom prst="rect">
             <a:avLst/>
@@ -5286,7 +5473,7 @@
         <p:spPr>
           <a:xfrm>
             <a:off x="6757560" y="1371600"/>
-            <a:ext cx="2011320" cy="2331360"/>
+            <a:ext cx="2010960" cy="2331000"/>
           </a:xfrm>
           <a:prstGeom prst="rect">
             <a:avLst/>
@@ -5319,6 +5506,11 @@
             <a:noAutofit/>
           </a:bodyPr>
           <a:p>
+            <a:pPr>
+              <a:lnSpc>
+                <a:spcPct val="100000"/>
+              </a:lnSpc>
+            </a:pPr>
             <a:endParaRPr lang="es-CO" sz="1800" b="0" u="none" strike="noStrike">
               <a:solidFill>
                 <a:srgbClr val="000000"/>
@@ -5339,7 +5531,7 @@
         <p:spPr>
           <a:xfrm>
             <a:off x="6757560" y="1371600"/>
-            <a:ext cx="2011320" cy="502560"/>
+            <a:ext cx="2010960" cy="502200"/>
           </a:xfrm>
           <a:prstGeom prst="rect">
             <a:avLst/>
@@ -5365,6 +5557,11 @@
             <a:noAutofit/>
           </a:bodyPr>
           <a:p>
+            <a:pPr>
+              <a:lnSpc>
+                <a:spcPct val="100000"/>
+              </a:lnSpc>
+            </a:pPr>
             <a:endParaRPr lang="es-CO" sz="1800" b="0" u="none" strike="noStrike">
               <a:solidFill>
                 <a:srgbClr val="ffffff"/>
@@ -5385,7 +5582,7 @@
         <p:spPr>
           <a:xfrm>
             <a:off x="6757560" y="1371600"/>
-            <a:ext cx="2011320" cy="502560"/>
+            <a:ext cx="2010960" cy="502200"/>
           </a:xfrm>
           <a:prstGeom prst="rect">
             <a:avLst/>
@@ -5446,7 +5643,7 @@
         <p:spPr>
           <a:xfrm>
             <a:off x="6757560" y="1901880"/>
-            <a:ext cx="2011320" cy="319680"/>
+            <a:ext cx="2010960" cy="319320"/>
           </a:xfrm>
           <a:prstGeom prst="rect">
             <a:avLst/>
@@ -5485,7 +5682,7 @@
                 <a:latin typeface="Consolas"/>
                 <a:ea typeface="Consolas"/>
               </a:rPr>
-              <a:t>04_cl uster_ml.i pynb</a:t>
+              <a:t>04_cluster_ml.ipynb</a:t>
             </a:r>
             <a:endParaRPr lang="es-CO" sz="800" b="0" u="none" strike="noStrike">
               <a:solidFill>
@@ -5507,7 +5704,7 @@
         <p:spPr>
           <a:xfrm>
             <a:off x="6757560" y="2212920"/>
-            <a:ext cx="2011320" cy="456840"/>
+            <a:ext cx="2010960" cy="456480"/>
           </a:xfrm>
           <a:prstGeom prst="rect">
             <a:avLst/>
@@ -5568,7 +5765,7 @@
         <p:spPr>
           <a:xfrm>
             <a:off x="6849000" y="2688480"/>
-            <a:ext cx="1828440" cy="914040"/>
+            <a:ext cx="1828080" cy="913680"/>
           </a:xfrm>
           <a:prstGeom prst="rect">
             <a:avLst/>
@@ -5696,7 +5893,7 @@
         <p:spPr>
           <a:xfrm>
             <a:off x="0" y="0"/>
-            <a:ext cx="109440" cy="5143320"/>
+            <a:ext cx="109080" cy="5142960"/>
           </a:xfrm>
           <a:prstGeom prst="rect">
             <a:avLst/>
@@ -5722,6 +5919,11 @@
             <a:noAutofit/>
           </a:bodyPr>
           <a:p>
+            <a:pPr>
+              <a:lnSpc>
+                <a:spcPct val="100000"/>
+              </a:lnSpc>
+            </a:pPr>
             <a:endParaRPr lang="es-CO" sz="1800" b="0" u="none" strike="noStrike">
               <a:solidFill>
                 <a:srgbClr val="ffffff"/>
@@ -5742,7 +5944,7 @@
         <p:spPr>
           <a:xfrm>
             <a:off x="365760" y="255960"/>
-            <a:ext cx="8503560" cy="566640"/>
+            <a:ext cx="8503200" cy="566280"/>
           </a:xfrm>
           <a:prstGeom prst="rect">
             <a:avLst/>
@@ -5803,7 +6005,7 @@
         <p:spPr>
           <a:xfrm>
             <a:off x="365760" y="822960"/>
-            <a:ext cx="8503560" cy="292320"/>
+            <a:ext cx="8503200" cy="291960"/>
           </a:xfrm>
           <a:prstGeom prst="rect">
             <a:avLst/>
@@ -5864,7 +6066,7 @@
         <p:spPr>
           <a:xfrm>
             <a:off x="365760" y="1188720"/>
-            <a:ext cx="2605680" cy="1416960"/>
+            <a:ext cx="2605320" cy="1416600"/>
           </a:xfrm>
           <a:prstGeom prst="rect">
             <a:avLst/>
@@ -5897,6 +6099,11 @@
             <a:noAutofit/>
           </a:bodyPr>
           <a:p>
+            <a:pPr>
+              <a:lnSpc>
+                <a:spcPct val="100000"/>
+              </a:lnSpc>
+            </a:pPr>
             <a:endParaRPr lang="es-CO" sz="1800" b="0" u="none" strike="noStrike">
               <a:solidFill>
                 <a:srgbClr val="000000"/>
@@ -5917,7 +6124,7 @@
         <p:spPr>
           <a:xfrm>
             <a:off x="365760" y="1188720"/>
-            <a:ext cx="2605680" cy="438480"/>
+            <a:ext cx="2605320" cy="438120"/>
           </a:xfrm>
           <a:prstGeom prst="rect">
             <a:avLst/>
@@ -5943,6 +6150,11 @@
             <a:noAutofit/>
           </a:bodyPr>
           <a:p>
+            <a:pPr>
+              <a:lnSpc>
+                <a:spcPct val="100000"/>
+              </a:lnSpc>
+            </a:pPr>
             <a:endParaRPr lang="es-CO" sz="1800" b="0" u="none" strike="noStrike">
               <a:solidFill>
                 <a:srgbClr val="ffffff"/>
@@ -5963,7 +6175,7 @@
         <p:spPr>
           <a:xfrm>
             <a:off x="365760" y="1188720"/>
-            <a:ext cx="2605680" cy="438480"/>
+            <a:ext cx="2605320" cy="438120"/>
           </a:xfrm>
           <a:prstGeom prst="rect">
             <a:avLst/>
@@ -6024,7 +6236,7 @@
         <p:spPr>
           <a:xfrm>
             <a:off x="457200" y="1664280"/>
-            <a:ext cx="2422800" cy="347040"/>
+            <a:ext cx="2422440" cy="346680"/>
           </a:xfrm>
           <a:prstGeom prst="rect">
             <a:avLst/>
@@ -6085,7 +6297,7 @@
         <p:spPr>
           <a:xfrm>
             <a:off x="457200" y="2011680"/>
-            <a:ext cx="2422800" cy="502560"/>
+            <a:ext cx="2422440" cy="502200"/>
           </a:xfrm>
           <a:prstGeom prst="rect">
             <a:avLst/>
@@ -6176,7 +6388,7 @@
         <p:spPr>
           <a:xfrm>
             <a:off x="3136320" y="1188720"/>
-            <a:ext cx="2605680" cy="1416960"/>
+            <a:ext cx="2605320" cy="1416600"/>
           </a:xfrm>
           <a:prstGeom prst="rect">
             <a:avLst/>
@@ -6209,6 +6421,11 @@
             <a:noAutofit/>
           </a:bodyPr>
           <a:p>
+            <a:pPr>
+              <a:lnSpc>
+                <a:spcPct val="100000"/>
+              </a:lnSpc>
+            </a:pPr>
             <a:endParaRPr lang="es-CO" sz="1800" b="0" u="none" strike="noStrike">
               <a:solidFill>
                 <a:srgbClr val="000000"/>
@@ -6229,7 +6446,7 @@
         <p:spPr>
           <a:xfrm>
             <a:off x="3136320" y="1188720"/>
-            <a:ext cx="2605680" cy="438480"/>
+            <a:ext cx="2605320" cy="438120"/>
           </a:xfrm>
           <a:prstGeom prst="rect">
             <a:avLst/>
@@ -6255,6 +6472,11 @@
             <a:noAutofit/>
           </a:bodyPr>
           <a:p>
+            <a:pPr>
+              <a:lnSpc>
+                <a:spcPct val="100000"/>
+              </a:lnSpc>
+            </a:pPr>
             <a:endParaRPr lang="es-CO" sz="1800" b="0" u="none" strike="noStrike">
               <a:solidFill>
                 <a:srgbClr val="ffffff"/>
@@ -6275,7 +6497,7 @@
         <p:spPr>
           <a:xfrm>
             <a:off x="3136320" y="1188720"/>
-            <a:ext cx="2605680" cy="438480"/>
+            <a:ext cx="2605320" cy="438120"/>
           </a:xfrm>
           <a:prstGeom prst="rect">
             <a:avLst/>
@@ -6336,7 +6558,7 @@
         <p:spPr>
           <a:xfrm>
             <a:off x="3227760" y="1664280"/>
-            <a:ext cx="2422800" cy="347040"/>
+            <a:ext cx="2422440" cy="346680"/>
           </a:xfrm>
           <a:prstGeom prst="rect">
             <a:avLst/>
@@ -6397,7 +6619,7 @@
         <p:spPr>
           <a:xfrm>
             <a:off x="3227760" y="2011680"/>
-            <a:ext cx="2422800" cy="502560"/>
+            <a:ext cx="2422440" cy="502200"/>
           </a:xfrm>
           <a:prstGeom prst="rect">
             <a:avLst/>
@@ -6488,7 +6710,7 @@
         <p:spPr>
           <a:xfrm>
             <a:off x="5906880" y="1188720"/>
-            <a:ext cx="2605680" cy="1416960"/>
+            <a:ext cx="2605320" cy="1416600"/>
           </a:xfrm>
           <a:prstGeom prst="rect">
             <a:avLst/>
@@ -6521,6 +6743,11 @@
             <a:noAutofit/>
           </a:bodyPr>
           <a:p>
+            <a:pPr>
+              <a:lnSpc>
+                <a:spcPct val="100000"/>
+              </a:lnSpc>
+            </a:pPr>
             <a:endParaRPr lang="es-CO" sz="1800" b="0" u="none" strike="noStrike">
               <a:solidFill>
                 <a:srgbClr val="000000"/>
@@ -6541,7 +6768,7 @@
         <p:spPr>
           <a:xfrm>
             <a:off x="5906880" y="1188720"/>
-            <a:ext cx="2605680" cy="438480"/>
+            <a:ext cx="2605320" cy="438120"/>
           </a:xfrm>
           <a:prstGeom prst="rect">
             <a:avLst/>
@@ -6567,6 +6794,11 @@
             <a:noAutofit/>
           </a:bodyPr>
           <a:p>
+            <a:pPr>
+              <a:lnSpc>
+                <a:spcPct val="100000"/>
+              </a:lnSpc>
+            </a:pPr>
             <a:endParaRPr lang="es-CO" sz="1800" b="0" u="none" strike="noStrike">
               <a:solidFill>
                 <a:srgbClr val="ffffff"/>
@@ -6587,7 +6819,7 @@
         <p:spPr>
           <a:xfrm>
             <a:off x="5906880" y="1188720"/>
-            <a:ext cx="2605680" cy="438480"/>
+            <a:ext cx="2605320" cy="438120"/>
           </a:xfrm>
           <a:prstGeom prst="rect">
             <a:avLst/>
@@ -6648,7 +6880,7 @@
         <p:spPr>
           <a:xfrm>
             <a:off x="5998320" y="1664280"/>
-            <a:ext cx="2422800" cy="347040"/>
+            <a:ext cx="2422440" cy="346680"/>
           </a:xfrm>
           <a:prstGeom prst="rect">
             <a:avLst/>
@@ -6709,7 +6941,7 @@
         <p:spPr>
           <a:xfrm>
             <a:off x="5998320" y="2011680"/>
-            <a:ext cx="2422800" cy="502560"/>
+            <a:ext cx="2422440" cy="502200"/>
           </a:xfrm>
           <a:prstGeom prst="rect">
             <a:avLst/>
@@ -6800,7 +7032,7 @@
         <p:spPr>
           <a:xfrm>
             <a:off x="365760" y="2606040"/>
-            <a:ext cx="8412120" cy="1005480"/>
+            <a:ext cx="8411760" cy="1005120"/>
           </a:xfrm>
           <a:prstGeom prst="rect">
             <a:avLst/>
@@ -6833,6 +7065,11 @@
             <a:noAutofit/>
           </a:bodyPr>
           <a:p>
+            <a:pPr>
+              <a:lnSpc>
+                <a:spcPct val="100000"/>
+              </a:lnSpc>
+            </a:pPr>
             <a:endParaRPr lang="es-CO" sz="1800" b="0" u="none" strike="noStrike">
               <a:solidFill>
                 <a:srgbClr val="ffffff"/>
@@ -6853,7 +7090,7 @@
         <p:spPr>
           <a:xfrm>
             <a:off x="548640" y="2651760"/>
-            <a:ext cx="1096920" cy="347040"/>
+            <a:ext cx="1096560" cy="346680"/>
           </a:xfrm>
           <a:prstGeom prst="rect">
             <a:avLst/>
@@ -6914,7 +7151,7 @@
         <p:spPr>
           <a:xfrm>
             <a:off x="548640" y="2999160"/>
-            <a:ext cx="8046360" cy="383760"/>
+            <a:ext cx="8046000" cy="383400"/>
           </a:xfrm>
           <a:prstGeom prst="rect">
             <a:avLst/>
@@ -6953,7 +7190,7 @@
                 <a:latin typeface="Consolas"/>
                 <a:ea typeface="Consolas"/>
               </a:rPr>
-              <a:t>compl_cri tical_ratio × 0.50  +  i ngr edi ents_qual it y_scor e × 0.35  +  (coplet eness + taxonomy) × 0.15</a:t>
+              <a:t>compl_critical_ratio × 0.50  +  ingredients_quality_score × 0.35  +  (copleteness + taxonomy) × 0.15</a:t>
             </a:r>
             <a:endParaRPr lang="es-CO" sz="1000" b="0" u="none" strike="noStrike">
               <a:solidFill>
@@ -6975,7 +7212,7 @@
         <p:spPr>
           <a:xfrm>
             <a:off x="1737360" y="2651760"/>
-            <a:ext cx="6857640" cy="347040"/>
+            <a:ext cx="6857280" cy="346680"/>
           </a:xfrm>
           <a:prstGeom prst="rect">
             <a:avLst/>
@@ -7014,7 +7251,7 @@
                 <a:latin typeface="Consolas"/>
                 <a:ea typeface="Consolas"/>
               </a:rPr>
-              <a:t>Si  dupl icado → score = 0.0   ·   Si n I ngr edi entes → scor e = -1</a:t>
+              <a:t>Si  dupl icado → score = 0.0   ·   Sin Ingredientes → score = -1</a:t>
             </a:r>
             <a:endParaRPr lang="es-CO" sz="1000" b="0" u="none" strike="noStrike">
               <a:solidFill>
@@ -7036,7 +7273,7 @@
         <p:spPr>
           <a:xfrm>
             <a:off x="365760" y="3749040"/>
-            <a:ext cx="8412120" cy="548280"/>
+            <a:ext cx="8411760" cy="547920"/>
           </a:xfrm>
           <a:prstGeom prst="rect">
             <a:avLst/>
@@ -7062,6 +7299,11 @@
             <a:noAutofit/>
           </a:bodyPr>
           <a:p>
+            <a:pPr>
+              <a:lnSpc>
+                <a:spcPct val="100000"/>
+              </a:lnSpc>
+            </a:pPr>
             <a:endParaRPr lang="es-CO" sz="1800" b="0" u="none" strike="noStrike">
               <a:solidFill>
                 <a:srgbClr val="000000"/>
@@ -7082,7 +7324,7 @@
         <p:spPr>
           <a:xfrm>
             <a:off x="457200" y="3749040"/>
-            <a:ext cx="8229240" cy="548280"/>
+            <a:ext cx="8228880" cy="547920"/>
           </a:xfrm>
           <a:prstGeom prst="rect">
             <a:avLst/>
@@ -7180,7 +7422,7 @@
         <p:spPr>
           <a:xfrm>
             <a:off x="0" y="0"/>
-            <a:ext cx="109440" cy="5143320"/>
+            <a:ext cx="109080" cy="5142960"/>
           </a:xfrm>
           <a:prstGeom prst="rect">
             <a:avLst/>
@@ -7206,6 +7448,11 @@
             <a:noAutofit/>
           </a:bodyPr>
           <a:p>
+            <a:pPr>
+              <a:lnSpc>
+                <a:spcPct val="100000"/>
+              </a:lnSpc>
+            </a:pPr>
             <a:endParaRPr lang="es-CO" sz="1800" b="0" u="none" strike="noStrike">
               <a:solidFill>
                 <a:srgbClr val="ffffff"/>
@@ -7226,7 +7473,7 @@
         <p:spPr>
           <a:xfrm>
             <a:off x="365760" y="182880"/>
-            <a:ext cx="8503560" cy="529920"/>
+            <a:ext cx="8503200" cy="529560"/>
           </a:xfrm>
           <a:prstGeom prst="rect">
             <a:avLst/>
@@ -7287,7 +7534,7 @@
         <p:spPr>
           <a:xfrm>
             <a:off x="365760" y="713160"/>
-            <a:ext cx="8503560" cy="255600"/>
+            <a:ext cx="8503200" cy="255240"/>
           </a:xfrm>
           <a:prstGeom prst="rect">
             <a:avLst/>
@@ -7352,7 +7599,7 @@
         <p:spPr>
           <a:xfrm>
             <a:off x="365760" y="1078920"/>
-            <a:ext cx="8412120" cy="2175840"/>
+            <a:ext cx="8411760" cy="2175480"/>
           </a:xfrm>
           <a:prstGeom prst="rect">
             <a:avLst/>
@@ -7372,7 +7619,7 @@
         <p:spPr>
           <a:xfrm>
             <a:off x="365760" y="3401640"/>
-            <a:ext cx="2651400" cy="1416960"/>
+            <a:ext cx="2651040" cy="1416600"/>
           </a:xfrm>
           <a:prstGeom prst="rect">
             <a:avLst/>
@@ -7405,6 +7652,11 @@
             <a:noAutofit/>
           </a:bodyPr>
           <a:p>
+            <a:pPr>
+              <a:lnSpc>
+                <a:spcPct val="100000"/>
+              </a:lnSpc>
+            </a:pPr>
             <a:endParaRPr lang="es-CO" sz="1800" b="0" u="none" strike="noStrike">
               <a:solidFill>
                 <a:srgbClr val="000000"/>
@@ -7425,7 +7677,7 @@
         <p:spPr>
           <a:xfrm>
             <a:off x="365760" y="3401640"/>
-            <a:ext cx="2651400" cy="54360"/>
+            <a:ext cx="2651040" cy="54000"/>
           </a:xfrm>
           <a:prstGeom prst="rect">
             <a:avLst/>
@@ -7451,6 +7703,11 @@
             <a:noAutofit/>
           </a:bodyPr>
           <a:p>
+            <a:pPr>
+              <a:lnSpc>
+                <a:spcPct val="100000"/>
+              </a:lnSpc>
+            </a:pPr>
             <a:endParaRPr lang="es-CO" sz="1800" b="0" u="none" strike="noStrike">
               <a:solidFill>
                 <a:srgbClr val="ffffff"/>
@@ -7471,7 +7728,7 @@
         <p:spPr>
           <a:xfrm>
             <a:off x="475560" y="3511440"/>
-            <a:ext cx="2431800" cy="301320"/>
+            <a:ext cx="2431440" cy="300960"/>
           </a:xfrm>
           <a:prstGeom prst="rect">
             <a:avLst/>
@@ -7532,7 +7789,7 @@
         <p:spPr>
           <a:xfrm>
             <a:off x="475560" y="3840480"/>
-            <a:ext cx="2431800" cy="868320"/>
+            <a:ext cx="2431440" cy="867960"/>
           </a:xfrm>
           <a:prstGeom prst="rect">
             <a:avLst/>
@@ -7593,7 +7850,7 @@
         <p:spPr>
           <a:xfrm>
             <a:off x="3154680" y="3401640"/>
-            <a:ext cx="2651400" cy="1416960"/>
+            <a:ext cx="2651040" cy="1416600"/>
           </a:xfrm>
           <a:prstGeom prst="rect">
             <a:avLst/>
@@ -7626,6 +7883,11 @@
             <a:noAutofit/>
           </a:bodyPr>
           <a:p>
+            <a:pPr>
+              <a:lnSpc>
+                <a:spcPct val="100000"/>
+              </a:lnSpc>
+            </a:pPr>
             <a:endParaRPr lang="es-CO" sz="1800" b="0" u="none" strike="noStrike">
               <a:solidFill>
                 <a:srgbClr val="000000"/>
@@ -7646,7 +7908,7 @@
         <p:spPr>
           <a:xfrm>
             <a:off x="3154680" y="3401640"/>
-            <a:ext cx="2651400" cy="54360"/>
+            <a:ext cx="2651040" cy="54000"/>
           </a:xfrm>
           <a:prstGeom prst="rect">
             <a:avLst/>
@@ -7672,6 +7934,11 @@
             <a:noAutofit/>
           </a:bodyPr>
           <a:p>
+            <a:pPr>
+              <a:lnSpc>
+                <a:spcPct val="100000"/>
+              </a:lnSpc>
+            </a:pPr>
             <a:endParaRPr lang="es-CO" sz="1800" b="0" u="none" strike="noStrike">
               <a:solidFill>
                 <a:srgbClr val="ffffff"/>
@@ -7692,7 +7959,7 @@
         <p:spPr>
           <a:xfrm>
             <a:off x="3264480" y="3511440"/>
-            <a:ext cx="2431800" cy="301320"/>
+            <a:ext cx="2431440" cy="300960"/>
           </a:xfrm>
           <a:prstGeom prst="rect">
             <a:avLst/>
@@ -7753,7 +8020,7 @@
         <p:spPr>
           <a:xfrm>
             <a:off x="3264480" y="3840480"/>
-            <a:ext cx="2431800" cy="868320"/>
+            <a:ext cx="2431440" cy="867960"/>
           </a:xfrm>
           <a:prstGeom prst="rect">
             <a:avLst/>
@@ -7814,7 +8081,7 @@
         <p:spPr>
           <a:xfrm>
             <a:off x="5943600" y="3401640"/>
-            <a:ext cx="2651400" cy="1416960"/>
+            <a:ext cx="2651040" cy="1416600"/>
           </a:xfrm>
           <a:prstGeom prst="rect">
             <a:avLst/>
@@ -7847,6 +8114,11 @@
             <a:noAutofit/>
           </a:bodyPr>
           <a:p>
+            <a:pPr>
+              <a:lnSpc>
+                <a:spcPct val="100000"/>
+              </a:lnSpc>
+            </a:pPr>
             <a:endParaRPr lang="es-CO" sz="1800" b="0" u="none" strike="noStrike">
               <a:solidFill>
                 <a:srgbClr val="000000"/>
@@ -7867,7 +8139,7 @@
         <p:spPr>
           <a:xfrm>
             <a:off x="5943600" y="3401640"/>
-            <a:ext cx="2651400" cy="54360"/>
+            <a:ext cx="2651040" cy="54000"/>
           </a:xfrm>
           <a:prstGeom prst="rect">
             <a:avLst/>
@@ -7893,6 +8165,11 @@
             <a:noAutofit/>
           </a:bodyPr>
           <a:p>
+            <a:pPr>
+              <a:lnSpc>
+                <a:spcPct val="100000"/>
+              </a:lnSpc>
+            </a:pPr>
             <a:endParaRPr lang="es-CO" sz="1800" b="0" u="none" strike="noStrike">
               <a:solidFill>
                 <a:srgbClr val="ffffff"/>
@@ -7913,7 +8190,7 @@
         <p:spPr>
           <a:xfrm>
             <a:off x="6053400" y="3511440"/>
-            <a:ext cx="2431800" cy="301320"/>
+            <a:ext cx="2431440" cy="300960"/>
           </a:xfrm>
           <a:prstGeom prst="rect">
             <a:avLst/>
@@ -7974,7 +8251,7 @@
         <p:spPr>
           <a:xfrm>
             <a:off x="6053400" y="3840480"/>
-            <a:ext cx="2431800" cy="868320"/>
+            <a:ext cx="2431440" cy="867960"/>
           </a:xfrm>
           <a:prstGeom prst="rect">
             <a:avLst/>
@@ -8072,7 +8349,7 @@
         <p:spPr>
           <a:xfrm>
             <a:off x="0" y="0"/>
-            <a:ext cx="109440" cy="5143320"/>
+            <a:ext cx="109080" cy="5142960"/>
           </a:xfrm>
           <a:prstGeom prst="rect">
             <a:avLst/>
@@ -8098,6 +8375,11 @@
             <a:noAutofit/>
           </a:bodyPr>
           <a:p>
+            <a:pPr>
+              <a:lnSpc>
+                <a:spcPct val="100000"/>
+              </a:lnSpc>
+            </a:pPr>
             <a:endParaRPr lang="es-CO" sz="1800" b="0" u="none" strike="noStrike">
               <a:solidFill>
                 <a:srgbClr val="ffffff"/>
@@ -8118,7 +8400,7 @@
         <p:spPr>
           <a:xfrm>
             <a:off x="365760" y="182880"/>
-            <a:ext cx="8503560" cy="529920"/>
+            <a:ext cx="8503200" cy="529560"/>
           </a:xfrm>
           <a:prstGeom prst="rect">
             <a:avLst/>
@@ -8179,7 +8461,7 @@
         <p:spPr>
           <a:xfrm>
             <a:off x="365760" y="713160"/>
-            <a:ext cx="8503560" cy="255600"/>
+            <a:ext cx="8503200" cy="255240"/>
           </a:xfrm>
           <a:prstGeom prst="rect">
             <a:avLst/>
@@ -8240,7 +8522,7 @@
         <p:spPr>
           <a:xfrm>
             <a:off x="365760" y="1051560"/>
-            <a:ext cx="2874240" cy="712800"/>
+            <a:ext cx="2873880" cy="712440"/>
           </a:xfrm>
           <a:prstGeom prst="rect">
             <a:avLst/>
@@ -8273,6 +8555,11 @@
             <a:noAutofit/>
           </a:bodyPr>
           <a:p>
+            <a:pPr>
+              <a:lnSpc>
+                <a:spcPct val="100000"/>
+              </a:lnSpc>
+            </a:pPr>
             <a:endParaRPr lang="es-CO" sz="1800" b="0" u="none" strike="noStrike">
               <a:solidFill>
                 <a:srgbClr val="000000"/>
@@ -8293,7 +8580,7 @@
         <p:spPr>
           <a:xfrm>
             <a:off x="365760" y="1051560"/>
-            <a:ext cx="63720" cy="712800"/>
+            <a:ext cx="63360" cy="712440"/>
           </a:xfrm>
           <a:prstGeom prst="rect">
             <a:avLst/>
@@ -8319,6 +8606,11 @@
             <a:noAutofit/>
           </a:bodyPr>
           <a:p>
+            <a:pPr>
+              <a:lnSpc>
+                <a:spcPct val="100000"/>
+              </a:lnSpc>
+            </a:pPr>
             <a:endParaRPr lang="es-CO" sz="1800" b="0" u="none" strike="noStrike">
               <a:solidFill>
                 <a:srgbClr val="ffffff"/>
@@ -8339,7 +8631,7 @@
         <p:spPr>
           <a:xfrm>
             <a:off x="548640" y="1097280"/>
-            <a:ext cx="3748680" cy="301320"/>
+            <a:ext cx="3748320" cy="300960"/>
           </a:xfrm>
           <a:prstGeom prst="rect">
             <a:avLst/>
@@ -8400,7 +8692,7 @@
         <p:spPr>
           <a:xfrm>
             <a:off x="548640" y="1417320"/>
-            <a:ext cx="3748680" cy="255600"/>
+            <a:ext cx="3748320" cy="255240"/>
           </a:xfrm>
           <a:prstGeom prst="rect">
             <a:avLst/>
@@ -8461,7 +8753,7 @@
         <p:spPr>
           <a:xfrm>
             <a:off x="365760" y="1856160"/>
-            <a:ext cx="2874240" cy="712800"/>
+            <a:ext cx="2873880" cy="712440"/>
           </a:xfrm>
           <a:prstGeom prst="rect">
             <a:avLst/>
@@ -8494,6 +8786,11 @@
             <a:noAutofit/>
           </a:bodyPr>
           <a:p>
+            <a:pPr>
+              <a:lnSpc>
+                <a:spcPct val="100000"/>
+              </a:lnSpc>
+            </a:pPr>
             <a:endParaRPr lang="es-CO" sz="1800" b="0" u="none" strike="noStrike">
               <a:solidFill>
                 <a:srgbClr val="000000"/>
@@ -8514,7 +8811,7 @@
         <p:spPr>
           <a:xfrm>
             <a:off x="365760" y="1856160"/>
-            <a:ext cx="63720" cy="712800"/>
+            <a:ext cx="63360" cy="712440"/>
           </a:xfrm>
           <a:prstGeom prst="rect">
             <a:avLst/>
@@ -8540,6 +8837,11 @@
             <a:noAutofit/>
           </a:bodyPr>
           <a:p>
+            <a:pPr>
+              <a:lnSpc>
+                <a:spcPct val="100000"/>
+              </a:lnSpc>
+            </a:pPr>
             <a:endParaRPr lang="es-CO" sz="1800" b="0" u="none" strike="noStrike">
               <a:solidFill>
                 <a:srgbClr val="ffffff"/>
@@ -8560,7 +8862,7 @@
         <p:spPr>
           <a:xfrm>
             <a:off x="548640" y="1901880"/>
-            <a:ext cx="3748680" cy="301320"/>
+            <a:ext cx="3748320" cy="300960"/>
           </a:xfrm>
           <a:prstGeom prst="rect">
             <a:avLst/>
@@ -8621,7 +8923,7 @@
         <p:spPr>
           <a:xfrm>
             <a:off x="548640" y="2221920"/>
-            <a:ext cx="3748680" cy="255600"/>
+            <a:ext cx="3748320" cy="255240"/>
           </a:xfrm>
           <a:prstGeom prst="rect">
             <a:avLst/>
@@ -8682,7 +8984,7 @@
         <p:spPr>
           <a:xfrm>
             <a:off x="365760" y="2660760"/>
-            <a:ext cx="2874240" cy="712800"/>
+            <a:ext cx="2873880" cy="712440"/>
           </a:xfrm>
           <a:prstGeom prst="rect">
             <a:avLst/>
@@ -8715,6 +9017,11 @@
             <a:noAutofit/>
           </a:bodyPr>
           <a:p>
+            <a:pPr>
+              <a:lnSpc>
+                <a:spcPct val="100000"/>
+              </a:lnSpc>
+            </a:pPr>
             <a:endParaRPr lang="es-CO" sz="1800" b="0" u="none" strike="noStrike">
               <a:solidFill>
                 <a:srgbClr val="000000"/>
@@ -8735,7 +9042,7 @@
         <p:spPr>
           <a:xfrm>
             <a:off x="365760" y="2660760"/>
-            <a:ext cx="63720" cy="712800"/>
+            <a:ext cx="63360" cy="712440"/>
           </a:xfrm>
           <a:prstGeom prst="rect">
             <a:avLst/>
@@ -8761,6 +9068,11 @@
             <a:noAutofit/>
           </a:bodyPr>
           <a:p>
+            <a:pPr>
+              <a:lnSpc>
+                <a:spcPct val="100000"/>
+              </a:lnSpc>
+            </a:pPr>
             <a:endParaRPr lang="es-CO" sz="1800" b="0" u="none" strike="noStrike">
               <a:solidFill>
                 <a:srgbClr val="ffffff"/>
@@ -8781,7 +9093,7 @@
         <p:spPr>
           <a:xfrm>
             <a:off x="548640" y="2706480"/>
-            <a:ext cx="3748680" cy="301320"/>
+            <a:ext cx="3748320" cy="300960"/>
           </a:xfrm>
           <a:prstGeom prst="rect">
             <a:avLst/>
@@ -8842,7 +9154,7 @@
         <p:spPr>
           <a:xfrm>
             <a:off x="548640" y="3026520"/>
-            <a:ext cx="3748680" cy="255600"/>
+            <a:ext cx="3748320" cy="255240"/>
           </a:xfrm>
           <a:prstGeom prst="rect">
             <a:avLst/>
@@ -8903,7 +9215,7 @@
         <p:spPr>
           <a:xfrm>
             <a:off x="365760" y="3465720"/>
-            <a:ext cx="2874240" cy="712800"/>
+            <a:ext cx="2873880" cy="712440"/>
           </a:xfrm>
           <a:prstGeom prst="rect">
             <a:avLst/>
@@ -8936,6 +9248,11 @@
             <a:noAutofit/>
           </a:bodyPr>
           <a:p>
+            <a:pPr>
+              <a:lnSpc>
+                <a:spcPct val="100000"/>
+              </a:lnSpc>
+            </a:pPr>
             <a:endParaRPr lang="es-CO" sz="1800" b="0" u="none" strike="noStrike">
               <a:solidFill>
                 <a:srgbClr val="000000"/>
@@ -8956,7 +9273,7 @@
         <p:spPr>
           <a:xfrm>
             <a:off x="365760" y="3465720"/>
-            <a:ext cx="63720" cy="712800"/>
+            <a:ext cx="63360" cy="712440"/>
           </a:xfrm>
           <a:prstGeom prst="rect">
             <a:avLst/>
@@ -8982,6 +9299,11 @@
             <a:noAutofit/>
           </a:bodyPr>
           <a:p>
+            <a:pPr>
+              <a:lnSpc>
+                <a:spcPct val="100000"/>
+              </a:lnSpc>
+            </a:pPr>
             <a:endParaRPr lang="es-CO" sz="1800" b="0" u="none" strike="noStrike">
               <a:solidFill>
                 <a:srgbClr val="ffffff"/>
@@ -9002,7 +9324,7 @@
         <p:spPr>
           <a:xfrm>
             <a:off x="548640" y="3511440"/>
-            <a:ext cx="3748680" cy="301320"/>
+            <a:ext cx="3748320" cy="300960"/>
           </a:xfrm>
           <a:prstGeom prst="rect">
             <a:avLst/>
@@ -9063,7 +9385,7 @@
         <p:spPr>
           <a:xfrm>
             <a:off x="548640" y="3831480"/>
-            <a:ext cx="3748680" cy="255600"/>
+            <a:ext cx="3748320" cy="255240"/>
           </a:xfrm>
           <a:prstGeom prst="rect">
             <a:avLst/>
@@ -9124,7 +9446,7 @@
         <p:spPr>
           <a:xfrm>
             <a:off x="365760" y="4270320"/>
-            <a:ext cx="2874240" cy="712800"/>
+            <a:ext cx="2873880" cy="712440"/>
           </a:xfrm>
           <a:prstGeom prst="rect">
             <a:avLst/>
@@ -9157,6 +9479,11 @@
             <a:noAutofit/>
           </a:bodyPr>
           <a:p>
+            <a:pPr>
+              <a:lnSpc>
+                <a:spcPct val="100000"/>
+              </a:lnSpc>
+            </a:pPr>
             <a:endParaRPr lang="es-CO" sz="1800" b="0" u="none" strike="noStrike">
               <a:solidFill>
                 <a:srgbClr val="000000"/>
@@ -9177,7 +9504,7 @@
         <p:spPr>
           <a:xfrm>
             <a:off x="365760" y="4270320"/>
-            <a:ext cx="63720" cy="712800"/>
+            <a:ext cx="63360" cy="712440"/>
           </a:xfrm>
           <a:prstGeom prst="rect">
             <a:avLst/>
@@ -9203,6 +9530,11 @@
             <a:noAutofit/>
           </a:bodyPr>
           <a:p>
+            <a:pPr>
+              <a:lnSpc>
+                <a:spcPct val="100000"/>
+              </a:lnSpc>
+            </a:pPr>
             <a:endParaRPr lang="es-CO" sz="1800" b="0" u="none" strike="noStrike">
               <a:solidFill>
                 <a:srgbClr val="ffffff"/>
@@ -9223,7 +9555,7 @@
         <p:spPr>
           <a:xfrm>
             <a:off x="548640" y="4316040"/>
-            <a:ext cx="3748680" cy="301320"/>
+            <a:ext cx="3748320" cy="300960"/>
           </a:xfrm>
           <a:prstGeom prst="rect">
             <a:avLst/>
@@ -9284,7 +9616,7 @@
         <p:spPr>
           <a:xfrm>
             <a:off x="548640" y="4636080"/>
-            <a:ext cx="3748680" cy="255600"/>
+            <a:ext cx="3748320" cy="255240"/>
           </a:xfrm>
           <a:prstGeom prst="rect">
             <a:avLst/>
@@ -9349,7 +9681,7 @@
         <p:spPr>
           <a:xfrm>
             <a:off x="3600000" y="865440"/>
-            <a:ext cx="4572000" cy="4174560"/>
+            <a:ext cx="4571640" cy="4174200"/>
           </a:xfrm>
           <a:prstGeom prst="rect">
             <a:avLst/>
@@ -9406,7 +9738,7 @@
         <p:spPr>
           <a:xfrm>
             <a:off x="0" y="0"/>
-            <a:ext cx="109440" cy="5143320"/>
+            <a:ext cx="109080" cy="5142960"/>
           </a:xfrm>
           <a:prstGeom prst="rect">
             <a:avLst/>
@@ -9432,6 +9764,11 @@
             <a:noAutofit/>
           </a:bodyPr>
           <a:p>
+            <a:pPr>
+              <a:lnSpc>
+                <a:spcPct val="100000"/>
+              </a:lnSpc>
+            </a:pPr>
             <a:endParaRPr lang="es-CO" sz="1800" b="0" u="none" strike="noStrike">
               <a:solidFill>
                 <a:srgbClr val="ffffff"/>
@@ -9452,7 +9789,7 @@
         <p:spPr>
           <a:xfrm>
             <a:off x="365760" y="255960"/>
-            <a:ext cx="8503560" cy="566640"/>
+            <a:ext cx="8503200" cy="566280"/>
           </a:xfrm>
           <a:prstGeom prst="rect">
             <a:avLst/>
@@ -9513,7 +9850,7 @@
         <p:spPr>
           <a:xfrm>
             <a:off x="365760" y="1051560"/>
-            <a:ext cx="1371240" cy="1005480"/>
+            <a:ext cx="1370880" cy="1005120"/>
           </a:xfrm>
           <a:prstGeom prst="rect">
             <a:avLst/>
@@ -9546,6 +9883,11 @@
             <a:noAutofit/>
           </a:bodyPr>
           <a:p>
+            <a:pPr>
+              <a:lnSpc>
+                <a:spcPct val="100000"/>
+              </a:lnSpc>
+            </a:pPr>
             <a:endParaRPr lang="es-CO" sz="1800" b="0" u="none" strike="noStrike">
               <a:solidFill>
                 <a:srgbClr val="ffffff"/>
@@ -9566,7 +9908,7 @@
         <p:spPr>
           <a:xfrm>
             <a:off x="365760" y="1051560"/>
-            <a:ext cx="1371240" cy="658080"/>
+            <a:ext cx="1370880" cy="657720"/>
           </a:xfrm>
           <a:prstGeom prst="rect">
             <a:avLst/>
@@ -9627,7 +9969,7 @@
         <p:spPr>
           <a:xfrm>
             <a:off x="365760" y="1710000"/>
-            <a:ext cx="1371240" cy="347040"/>
+            <a:ext cx="1370880" cy="346680"/>
           </a:xfrm>
           <a:prstGeom prst="rect">
             <a:avLst/>
@@ -9688,7 +10030,7 @@
         <p:spPr>
           <a:xfrm>
             <a:off x="1920240" y="1188720"/>
-            <a:ext cx="6857640" cy="776880"/>
+            <a:ext cx="6857280" cy="776520"/>
           </a:xfrm>
           <a:prstGeom prst="rect">
             <a:avLst/>
@@ -9779,7 +10121,7 @@
         <p:spPr>
           <a:xfrm>
             <a:off x="365760" y="2286000"/>
-            <a:ext cx="1371240" cy="1005480"/>
+            <a:ext cx="1370880" cy="1005120"/>
           </a:xfrm>
           <a:prstGeom prst="rect">
             <a:avLst/>
@@ -9812,6 +10154,11 @@
             <a:noAutofit/>
           </a:bodyPr>
           <a:p>
+            <a:pPr>
+              <a:lnSpc>
+                <a:spcPct val="100000"/>
+              </a:lnSpc>
+            </a:pPr>
             <a:endParaRPr lang="es-CO" sz="1800" b="0" u="none" strike="noStrike">
               <a:solidFill>
                 <a:srgbClr val="ffffff"/>
@@ -9832,7 +10179,7 @@
         <p:spPr>
           <a:xfrm>
             <a:off x="365760" y="2286000"/>
-            <a:ext cx="1371240" cy="658080"/>
+            <a:ext cx="1370880" cy="657720"/>
           </a:xfrm>
           <a:prstGeom prst="rect">
             <a:avLst/>
@@ -9893,7 +10240,7 @@
         <p:spPr>
           <a:xfrm>
             <a:off x="365760" y="2944440"/>
-            <a:ext cx="1371240" cy="347040"/>
+            <a:ext cx="1370880" cy="346680"/>
           </a:xfrm>
           <a:prstGeom prst="rect">
             <a:avLst/>
@@ -9954,7 +10301,7 @@
         <p:spPr>
           <a:xfrm>
             <a:off x="1920240" y="2423160"/>
-            <a:ext cx="6857640" cy="776880"/>
+            <a:ext cx="6857280" cy="776520"/>
           </a:xfrm>
           <a:prstGeom prst="rect">
             <a:avLst/>
@@ -10045,7 +10392,7 @@
         <p:spPr>
           <a:xfrm>
             <a:off x="365760" y="3520440"/>
-            <a:ext cx="1371240" cy="1005480"/>
+            <a:ext cx="1370880" cy="1005120"/>
           </a:xfrm>
           <a:prstGeom prst="rect">
             <a:avLst/>
@@ -10078,6 +10425,11 @@
             <a:noAutofit/>
           </a:bodyPr>
           <a:p>
+            <a:pPr>
+              <a:lnSpc>
+                <a:spcPct val="100000"/>
+              </a:lnSpc>
+            </a:pPr>
             <a:endParaRPr lang="es-CO" sz="1800" b="0" u="none" strike="noStrike">
               <a:solidFill>
                 <a:srgbClr val="ffffff"/>
@@ -10098,7 +10450,7 @@
         <p:spPr>
           <a:xfrm>
             <a:off x="365760" y="3520440"/>
-            <a:ext cx="1371240" cy="658080"/>
+            <a:ext cx="1370880" cy="657720"/>
           </a:xfrm>
           <a:prstGeom prst="rect">
             <a:avLst/>
@@ -10159,7 +10511,7 @@
         <p:spPr>
           <a:xfrm>
             <a:off x="365760" y="4178880"/>
-            <a:ext cx="1371240" cy="347040"/>
+            <a:ext cx="1370880" cy="346680"/>
           </a:xfrm>
           <a:prstGeom prst="rect">
             <a:avLst/>
@@ -10220,7 +10572,7 @@
         <p:spPr>
           <a:xfrm>
             <a:off x="1920240" y="3657600"/>
-            <a:ext cx="6857640" cy="776880"/>
+            <a:ext cx="6857280" cy="776520"/>
           </a:xfrm>
           <a:prstGeom prst="rect">
             <a:avLst/>
@@ -10348,7 +10700,7 @@
         <p:spPr>
           <a:xfrm>
             <a:off x="0" y="0"/>
-            <a:ext cx="164160" cy="5143320"/>
+            <a:ext cx="163800" cy="5142960"/>
           </a:xfrm>
           <a:prstGeom prst="rect">
             <a:avLst/>
@@ -10374,6 +10726,11 @@
             <a:noAutofit/>
           </a:bodyPr>
           <a:p>
+            <a:pPr>
+              <a:lnSpc>
+                <a:spcPct val="100000"/>
+              </a:lnSpc>
+            </a:pPr>
             <a:endParaRPr lang="es-CO" sz="1800" b="0" u="none" strike="noStrike">
               <a:solidFill>
                 <a:srgbClr val="ffffff"/>
@@ -10394,7 +10751,7 @@
         <p:spPr>
           <a:xfrm>
             <a:off x="164520" y="0"/>
-            <a:ext cx="54360" cy="5143320"/>
+            <a:ext cx="54000" cy="5142960"/>
           </a:xfrm>
           <a:prstGeom prst="rect">
             <a:avLst/>
@@ -10420,6 +10777,11 @@
             <a:noAutofit/>
           </a:bodyPr>
           <a:p>
+            <a:pPr>
+              <a:lnSpc>
+                <a:spcPct val="100000"/>
+              </a:lnSpc>
+            </a:pPr>
             <a:endParaRPr lang="es-CO" sz="1800" b="0" u="none" strike="noStrike">
               <a:solidFill>
                 <a:srgbClr val="ffffff"/>
@@ -10440,7 +10802,7 @@
         <p:spPr>
           <a:xfrm>
             <a:off x="548640" y="1005840"/>
-            <a:ext cx="8229240" cy="914040"/>
+            <a:ext cx="8228880" cy="913680"/>
           </a:xfrm>
           <a:prstGeom prst="rect">
             <a:avLst/>
@@ -10501,7 +10863,7 @@
         <p:spPr>
           <a:xfrm>
             <a:off x="548640" y="2057400"/>
-            <a:ext cx="8229240" cy="1234080"/>
+            <a:ext cx="8228880" cy="1233720"/>
           </a:xfrm>
           <a:prstGeom prst="rect">
             <a:avLst/>
@@ -10665,7 +11027,7 @@
         <p:spPr>
           <a:xfrm>
             <a:off x="548640" y="3566160"/>
-            <a:ext cx="8229240" cy="365400"/>
+            <a:ext cx="8228880" cy="365040"/>
           </a:xfrm>
           <a:prstGeom prst="rect">
             <a:avLst/>
@@ -10726,7 +11088,7 @@
         <p:spPr>
           <a:xfrm>
             <a:off x="548640" y="3977640"/>
-            <a:ext cx="8229240" cy="319680"/>
+            <a:ext cx="8228880" cy="319320"/>
           </a:xfrm>
           <a:prstGeom prst="rect">
             <a:avLst/>
@@ -10778,36 +11140,6 @@
           </a:p>
         </p:txBody>
       </p:sp>
-    </p:spTree>
-  </p:cSld>
-  <mc:AlternateContent>
-    <mc:Choice Requires="p14">
-      <p:transition spd="slow" p14:dur="2000"/>
-    </mc:Choice>
-    <mc:Fallback>
-      <p:transition spd="slow"/>
-    </mc:Fallback>
-  </mc:AlternateContent>
-</p:sld>
-</file>
-
-<file path=ppt/slides/slide9.xml><?xml version="1.0" encoding="utf-8"?>
-<p:sld xmlns:a="http://schemas.openxmlformats.org/drawingml/2006/main" xmlns:p="http://schemas.openxmlformats.org/presentationml/2006/main" xmlns:r="http://schemas.openxmlformats.org/officeDocument/2006/relationships" xmlns:p14="http://schemas.microsoft.com/office/powerpoint/2010/main" xmlns:p15="http://schemas.microsoft.com/office/powerpoint/2012/main" xmlns:mc="http://schemas.openxmlformats.org/markup-compatibility/2006">
-  <p:cSld>
-    <p:spTree>
-      <p:nvGrpSpPr>
-        <p:cNvPr id="1" name=""/>
-        <p:cNvGrpSpPr/>
-        <p:nvPr/>
-      </p:nvGrpSpPr>
-      <p:grpSpPr>
-        <a:xfrm>
-          <a:off x="0" y="0"/>
-          <a:ext cx="0" cy="0"/>
-          <a:chOff x="0" y="0"/>
-          <a:chExt cx="0" cy="0"/>
-        </a:xfrm>
-      </p:grpSpPr>
     </p:spTree>
   </p:cSld>
   <mc:AlternateContent>

</xml_diff>